<commit_message>
feat(report,slides): cross-validated results, merged across separately-run models
cv_report.load() now assembles from the per-model cv_<model>.json files, which are rewritten
after every fold. The two models do not cost the same per epoch -- CNN+LSTM runs at 146s/epoch
against YOLO12's 55s -- so matching their epoch budgets means running them with different
wall-clock caps, and a split run must be indistinguishable from a single one. It also means an
interrupted run still reports whatever completed.

Slide deck rebuilt around the cross-validated numbers, with a new slide making the central
point explicit: the problem was memorisation, not architecture, and the fix list deliberately
does not include 'train longer'.
</commit_message>
<xml_diff>
--- a/slides/Techathon_PS6.pptx
+++ b/slides/Techathon_PS6.pptx
@@ -19,6 +19,9 @@
     <p:sldId id="267" r:id="rId18"/>
     <p:sldId id="268" r:id="rId19"/>
     <p:sldId id="269" r:id="rId20"/>
+    <p:sldId id="270" r:id="rId21"/>
+    <p:sldId id="271" r:id="rId22"/>
+    <p:sldId id="272" r:id="rId23"/>
   </p:sldIdLst>
   <p:sldSz cx="12191695" cy="6858000" type="screen4x3"/>
   <p:notesSz cx="6858000" cy="9144000"/>
@@ -3253,21 +3256,545 @@
               </a:defRPr>
             </a:pPr>
             <a:r>
-              <a:t>Results</a:t>
-            </a:r>
-          </a:p>
-        </p:txBody>
-      </p:sp>
-      <p:sp>
-        <p:nvSpPr>
-          <p:cNvPr id="3" name="TextBox 2"/>
+              <a:t>Progressive data scaling</a:t>
+            </a:r>
+          </a:p>
+          <a:p>
+            <a:pPr>
+              <a:defRPr sz="1300">
+                <a:solidFill>
+                  <a:srgbClr val="475569"/>
+                </a:solidFill>
+              </a:defRPr>
+            </a:pPr>
+            <a:r>
+              <a:t>Start small; step up only as far as the machine demonstrably sustains</a:t>
+            </a:r>
+          </a:p>
+        </p:txBody>
+      </p:sp>
+      <p:graphicFrame>
+        <p:nvGraphicFramePr>
+          <p:cNvPr id="3" name="Table 2"/>
+          <p:cNvGraphicFramePr>
+            <a:graphicFrameLocks noGrp="1"/>
+          </p:cNvGraphicFramePr>
+          <p:nvPr/>
+        </p:nvGraphicFramePr>
+        <p:xfrm>
+          <a:off x="640080" y="1371600"/>
+          <a:ext cx="6583680" cy="2651760"/>
+        </p:xfrm>
+        <a:graphic>
+          <a:graphicData uri="http://schemas.openxmlformats.org/drawingml/2006/table">
+            <a:tbl>
+              <a:tblPr firstRow="1" bandRow="1">
+                <a:tableStyleId>{5C22544A-7EE6-4342-B048-85BDC9FD1C3A}</a:tableStyleId>
+              </a:tblPr>
+              <a:tblGrid>
+                <a:gridCol w="1645920"/>
+                <a:gridCol w="1645920"/>
+                <a:gridCol w="1645920"/>
+                <a:gridCol w="1645920"/>
+              </a:tblGrid>
+              <a:tr h="441960">
+                <a:tc>
+                  <a:txBody>
+                    <a:bodyPr/>
+                    <a:lstStyle/>
+                    <a:p>
+                      <a:pPr>
+                        <a:defRPr sz="1100" b="1">
+                          <a:solidFill>
+                            <a:srgbClr val="FFFFFF"/>
+                          </a:solidFill>
+                        </a:defRPr>
+                      </a:pPr>
+                      <a:r>
+                        <a:t>Tier</a:t>
+                      </a:r>
+                    </a:p>
+                  </a:txBody>
+                  <a:tcPr>
+                    <a:solidFill>
+                      <a:srgbClr val="0F233E"/>
+                    </a:solidFill>
+                  </a:tcPr>
+                </a:tc>
+                <a:tc>
+                  <a:txBody>
+                    <a:bodyPr/>
+                    <a:lstStyle/>
+                    <a:p>
+                      <a:pPr>
+                        <a:defRPr sz="1100" b="1">
+                          <a:solidFill>
+                            <a:srgbClr val="FFFFFF"/>
+                          </a:solidFill>
+                        </a:defRPr>
+                      </a:pPr>
+                      <a:r>
+                        <a:t>Tiles</a:t>
+                      </a:r>
+                    </a:p>
+                  </a:txBody>
+                  <a:tcPr>
+                    <a:solidFill>
+                      <a:srgbClr val="0F233E"/>
+                    </a:solidFill>
+                  </a:tcPr>
+                </a:tc>
+                <a:tc>
+                  <a:txBody>
+                    <a:bodyPr/>
+                    <a:lstStyle/>
+                    <a:p>
+                      <a:pPr>
+                        <a:defRPr sz="1100" b="1">
+                          <a:solidFill>
+                            <a:srgbClr val="FFFFFF"/>
+                          </a:solidFill>
+                        </a:defRPr>
+                      </a:pPr>
+                      <a:r>
+                        <a:t>Size</a:t>
+                      </a:r>
+                    </a:p>
+                  </a:txBody>
+                  <a:tcPr>
+                    <a:solidFill>
+                      <a:srgbClr val="0F233E"/>
+                    </a:solidFill>
+                  </a:tcPr>
+                </a:tc>
+                <a:tc>
+                  <a:txBody>
+                    <a:bodyPr/>
+                    <a:lstStyle/>
+                    <a:p>
+                      <a:pPr>
+                        <a:defRPr sz="1100" b="1">
+                          <a:solidFill>
+                            <a:srgbClr val="FFFFFF"/>
+                          </a:solidFill>
+                        </a:defRPr>
+                      </a:pPr>
+                      <a:r>
+                        <a:t>Purpose</a:t>
+                      </a:r>
+                    </a:p>
+                  </a:txBody>
+                  <a:tcPr>
+                    <a:solidFill>
+                      <a:srgbClr val="0F233E"/>
+                    </a:solidFill>
+                  </a:tcPr>
+                </a:tc>
+              </a:tr>
+              <a:tr h="441960">
+                <a:tc>
+                  <a:txBody>
+                    <a:bodyPr/>
+                    <a:lstStyle/>
+                    <a:p>
+                      <a:pPr>
+                        <a:defRPr sz="1100">
+                          <a:solidFill>
+                            <a:srgbClr val="0F233E"/>
+                          </a:solidFill>
+                        </a:defRPr>
+                      </a:pPr>
+                      <a:r>
+                        <a:t>T0_smoke</a:t>
+                      </a:r>
+                    </a:p>
+                  </a:txBody>
+                  <a:tcPr/>
+                </a:tc>
+                <a:tc>
+                  <a:txBody>
+                    <a:bodyPr/>
+                    <a:lstStyle/>
+                    <a:p>
+                      <a:pPr>
+                        <a:defRPr sz="1100">
+                          <a:solidFill>
+                            <a:srgbClr val="0F233E"/>
+                          </a:solidFill>
+                        </a:defRPr>
+                      </a:pPr>
+                      <a:r>
+                        <a:t>40</a:t>
+                      </a:r>
+                    </a:p>
+                  </a:txBody>
+                  <a:tcPr/>
+                </a:tc>
+                <a:tc>
+                  <a:txBody>
+                    <a:bodyPr/>
+                    <a:lstStyle/>
+                    <a:p>
+                      <a:pPr>
+                        <a:defRPr sz="1100">
+                          <a:solidFill>
+                            <a:srgbClr val="0F233E"/>
+                          </a:solidFill>
+                        </a:defRPr>
+                      </a:pPr>
+                      <a:r>
+                        <a:t>128 px</a:t>
+                      </a:r>
+                    </a:p>
+                  </a:txBody>
+                  <a:tcPr/>
+                </a:tc>
+                <a:tc>
+                  <a:txBody>
+                    <a:bodyPr/>
+                    <a:lstStyle/>
+                    <a:p>
+                      <a:pPr>
+                        <a:defRPr sz="1100">
+                          <a:solidFill>
+                            <a:srgbClr val="0F233E"/>
+                          </a:solidFill>
+                        </a:defRPr>
+                      </a:pPr>
+                      <a:r>
+                        <a:t>Pipeline proof — offline, runs in CI</a:t>
+                      </a:r>
+                    </a:p>
+                  </a:txBody>
+                  <a:tcPr/>
+                </a:tc>
+              </a:tr>
+              <a:tr h="441960">
+                <a:tc>
+                  <a:txBody>
+                    <a:bodyPr/>
+                    <a:lstStyle/>
+                    <a:p>
+                      <a:pPr>
+                        <a:defRPr sz="1100">
+                          <a:solidFill>
+                            <a:srgbClr val="0F233E"/>
+                          </a:solidFill>
+                        </a:defRPr>
+                      </a:pPr>
+                      <a:r>
+                        <a:t>T1_tiny</a:t>
+                      </a:r>
+                    </a:p>
+                  </a:txBody>
+                  <a:tcPr/>
+                </a:tc>
+                <a:tc>
+                  <a:txBody>
+                    <a:bodyPr/>
+                    <a:lstStyle/>
+                    <a:p>
+                      <a:pPr>
+                        <a:defRPr sz="1100">
+                          <a:solidFill>
+                            <a:srgbClr val="0F233E"/>
+                          </a:solidFill>
+                        </a:defRPr>
+                      </a:pPr>
+                      <a:r>
+                        <a:t>150</a:t>
+                      </a:r>
+                    </a:p>
+                  </a:txBody>
+                  <a:tcPr/>
+                </a:tc>
+                <a:tc>
+                  <a:txBody>
+                    <a:bodyPr/>
+                    <a:lstStyle/>
+                    <a:p>
+                      <a:pPr>
+                        <a:defRPr sz="1100">
+                          <a:solidFill>
+                            <a:srgbClr val="0F233E"/>
+                          </a:solidFill>
+                        </a:defRPr>
+                      </a:pPr>
+                      <a:r>
+                        <a:t>128 px</a:t>
+                      </a:r>
+                    </a:p>
+                  </a:txBody>
+                  <a:tcPr/>
+                </a:tc>
+                <a:tc>
+                  <a:txBody>
+                    <a:bodyPr/>
+                    <a:lstStyle/>
+                    <a:p>
+                      <a:pPr>
+                        <a:defRPr sz="1100">
+                          <a:solidFill>
+                            <a:srgbClr val="0F233E"/>
+                          </a:solidFill>
+                        </a:defRPr>
+                      </a:pPr>
+                      <a:r>
+                        <a:t>First real data</a:t>
+                      </a:r>
+                    </a:p>
+                  </a:txBody>
+                  <a:tcPr/>
+                </a:tc>
+              </a:tr>
+              <a:tr h="441960">
+                <a:tc>
+                  <a:txBody>
+                    <a:bodyPr/>
+                    <a:lstStyle/>
+                    <a:p>
+                      <a:pPr>
+                        <a:defRPr sz="1100">
+                          <a:solidFill>
+                            <a:srgbClr val="0F233E"/>
+                          </a:solidFill>
+                        </a:defRPr>
+                      </a:pPr>
+                      <a:r>
+                        <a:t>T2_small</a:t>
+                      </a:r>
+                    </a:p>
+                  </a:txBody>
+                  <a:tcPr/>
+                </a:tc>
+                <a:tc>
+                  <a:txBody>
+                    <a:bodyPr/>
+                    <a:lstStyle/>
+                    <a:p>
+                      <a:pPr>
+                        <a:defRPr sz="1100">
+                          <a:solidFill>
+                            <a:srgbClr val="0F233E"/>
+                          </a:solidFill>
+                        </a:defRPr>
+                      </a:pPr>
+                      <a:r>
+                        <a:t>400</a:t>
+                      </a:r>
+                    </a:p>
+                  </a:txBody>
+                  <a:tcPr/>
+                </a:tc>
+                <a:tc>
+                  <a:txBody>
+                    <a:bodyPr/>
+                    <a:lstStyle/>
+                    <a:p>
+                      <a:pPr>
+                        <a:defRPr sz="1100">
+                          <a:solidFill>
+                            <a:srgbClr val="0F233E"/>
+                          </a:solidFill>
+                        </a:defRPr>
+                      </a:pPr>
+                      <a:r>
+                        <a:t>192 px</a:t>
+                      </a:r>
+                    </a:p>
+                  </a:txBody>
+                  <a:tcPr/>
+                </a:tc>
+                <a:tc>
+                  <a:txBody>
+                    <a:bodyPr/>
+                    <a:lstStyle/>
+                    <a:p>
+                      <a:pPr>
+                        <a:defRPr sz="1100">
+                          <a:solidFill>
+                            <a:srgbClr val="0F233E"/>
+                          </a:solidFill>
+                        </a:defRPr>
+                      </a:pPr>
+                      <a:r>
+                        <a:t>First meaningful signal</a:t>
+                      </a:r>
+                    </a:p>
+                  </a:txBody>
+                  <a:tcPr/>
+                </a:tc>
+              </a:tr>
+              <a:tr h="441960">
+                <a:tc>
+                  <a:txBody>
+                    <a:bodyPr/>
+                    <a:lstStyle/>
+                    <a:p>
+                      <a:pPr>
+                        <a:defRPr sz="1100">
+                          <a:solidFill>
+                            <a:srgbClr val="0F233E"/>
+                          </a:solidFill>
+                        </a:defRPr>
+                      </a:pPr>
+                      <a:r>
+                        <a:t>T3_medium</a:t>
+                      </a:r>
+                    </a:p>
+                  </a:txBody>
+                  <a:tcPr/>
+                </a:tc>
+                <a:tc>
+                  <a:txBody>
+                    <a:bodyPr/>
+                    <a:lstStyle/>
+                    <a:p>
+                      <a:pPr>
+                        <a:defRPr sz="1100">
+                          <a:solidFill>
+                            <a:srgbClr val="0F233E"/>
+                          </a:solidFill>
+                        </a:defRPr>
+                      </a:pPr>
+                      <a:r>
+                        <a:t>900</a:t>
+                      </a:r>
+                    </a:p>
+                  </a:txBody>
+                  <a:tcPr/>
+                </a:tc>
+                <a:tc>
+                  <a:txBody>
+                    <a:bodyPr/>
+                    <a:lstStyle/>
+                    <a:p>
+                      <a:pPr>
+                        <a:defRPr sz="1100">
+                          <a:solidFill>
+                            <a:srgbClr val="0F233E"/>
+                          </a:solidFill>
+                        </a:defRPr>
+                      </a:pPr>
+                      <a:r>
+                        <a:t>256 px</a:t>
+                      </a:r>
+                    </a:p>
+                  </a:txBody>
+                  <a:tcPr/>
+                </a:tc>
+                <a:tc>
+                  <a:txBody>
+                    <a:bodyPr/>
+                    <a:lstStyle/>
+                    <a:p>
+                      <a:pPr>
+                        <a:defRPr sz="1100">
+                          <a:solidFill>
+                            <a:srgbClr val="0F233E"/>
+                          </a:solidFill>
+                        </a:defRPr>
+                      </a:pPr>
+                      <a:r>
+                        <a:t>Target tier</a:t>
+                      </a:r>
+                    </a:p>
+                  </a:txBody>
+                  <a:tcPr/>
+                </a:tc>
+              </a:tr>
+              <a:tr h="441960">
+                <a:tc>
+                  <a:txBody>
+                    <a:bodyPr/>
+                    <a:lstStyle/>
+                    <a:p>
+                      <a:pPr>
+                        <a:defRPr sz="1100">
+                          <a:solidFill>
+                            <a:srgbClr val="0F233E"/>
+                          </a:solidFill>
+                        </a:defRPr>
+                      </a:pPr>
+                      <a:r>
+                        <a:t>T4_large</a:t>
+                      </a:r>
+                    </a:p>
+                  </a:txBody>
+                  <a:tcPr/>
+                </a:tc>
+                <a:tc>
+                  <a:txBody>
+                    <a:bodyPr/>
+                    <a:lstStyle/>
+                    <a:p>
+                      <a:pPr>
+                        <a:defRPr sz="1100">
+                          <a:solidFill>
+                            <a:srgbClr val="0F233E"/>
+                          </a:solidFill>
+                        </a:defRPr>
+                      </a:pPr>
+                      <a:r>
+                        <a:t>1800</a:t>
+                      </a:r>
+                    </a:p>
+                  </a:txBody>
+                  <a:tcPr/>
+                </a:tc>
+                <a:tc>
+                  <a:txBody>
+                    <a:bodyPr/>
+                    <a:lstStyle/>
+                    <a:p>
+                      <a:pPr>
+                        <a:defRPr sz="1100">
+                          <a:solidFill>
+                            <a:srgbClr val="0F233E"/>
+                          </a:solidFill>
+                        </a:defRPr>
+                      </a:pPr>
+                      <a:r>
+                        <a:t>256 px</a:t>
+                      </a:r>
+                    </a:p>
+                  </a:txBody>
+                  <a:tcPr/>
+                </a:tc>
+                <a:tc>
+                  <a:txBody>
+                    <a:bodyPr/>
+                    <a:lstStyle/>
+                    <a:p>
+                      <a:pPr>
+                        <a:defRPr sz="1100">
+                          <a:solidFill>
+                            <a:srgbClr val="0F233E"/>
+                          </a:solidFill>
+                        </a:defRPr>
+                      </a:pPr>
+                      <a:r>
+                        <a:t>Only if T3 finished comfortably</a:t>
+                      </a:r>
+                    </a:p>
+                  </a:txBody>
+                  <a:tcPr/>
+                </a:tc>
+              </a:tr>
+            </a:tbl>
+          </a:graphicData>
+        </a:graphic>
+      </p:graphicFrame>
+      <p:sp>
+        <p:nvSpPr>
+          <p:cNvPr id="4" name="TextBox 3"/>
           <p:cNvSpPr txBox="1"/>
           <p:nvPr/>
         </p:nvSpPr>
         <p:spPr>
           <a:xfrm>
-            <a:off x="640080" y="1417320"/>
-            <a:ext cx="10972800" cy="4846320"/>
+            <a:off x="7498079" y="1463040"/>
+            <a:ext cx="4206240" cy="4846320"/>
           </a:xfrm>
           <a:prstGeom prst="rect">
             <a:avLst/>
@@ -3282,16 +3809,61 @@
           <a:p>
             <a:pPr>
               <a:spcAft>
-                <a:spcPts val="800"/>
+                <a:spcPts val="1000"/>
               </a:spcAft>
-              <a:defRPr sz="1500">
+              <a:defRPr sz="1200">
                 <a:solidFill>
                   <a:srgbClr val="0F233E"/>
                 </a:solidFill>
               </a:defRPr>
             </a:pPr>
             <a:r>
-              <a:t>• Training run in progress — regenerate this deck with `python scripts_make_slides.py`.</a:t>
+              <a:t>• After each tier we measure peak RSS, free disk and seconds/epoch</a:t>
+            </a:r>
+          </a:p>
+          <a:p>
+            <a:pPr>
+              <a:spcAft>
+                <a:spcPts val="1000"/>
+              </a:spcAft>
+              <a:defRPr sz="1200">
+                <a:solidFill>
+                  <a:srgbClr val="0F233E"/>
+                </a:solidFill>
+              </a:defRPr>
+            </a:pPr>
+            <a:r>
+              <a:t>• Advance only if the next tier stays under a 6 GB disk floor, 70% of RAM and the time budget</a:t>
+            </a:r>
+          </a:p>
+          <a:p>
+            <a:pPr>
+              <a:spcAft>
+                <a:spcPts val="1000"/>
+              </a:spcAft>
+              <a:defRPr sz="1200">
+                <a:solidFill>
+                  <a:srgbClr val="0F233E"/>
+                </a:solidFill>
+              </a:defRPr>
+            </a:pPr>
+            <a:r>
+              <a:t>• Otherwise stop at the last good tier and record why — in reports/scaling_log.json</a:t>
+            </a:r>
+          </a:p>
+          <a:p>
+            <a:pPr>
+              <a:spcAft>
+                <a:spcPts val="1000"/>
+              </a:spcAft>
+              <a:defRPr sz="1200">
+                <a:solidFill>
+                  <a:srgbClr val="0F233E"/>
+                </a:solidFill>
+              </a:defRPr>
+            </a:pPr>
+            <a:r>
+              <a:t>• A complete five-model table exists after the first tier, so there is always something to show</a:t>
             </a:r>
           </a:p>
         </p:txBody>
@@ -3344,7 +3916,7 @@
               </a:defRPr>
             </a:pPr>
             <a:r>
-              <a:t>Working demo</a:t>
+              <a:t>Results — 5-fold cross validation</a:t>
             </a:r>
           </a:p>
           <a:p>
@@ -3356,21 +3928,393 @@
               </a:defRPr>
             </a:pPr>
             <a:r>
-              <a:t>streamlit run app/streamlit_app.py</a:t>
-            </a:r>
-          </a:p>
-        </p:txBody>
-      </p:sp>
-      <p:sp>
-        <p:nvSpPr>
-          <p:cNvPr id="3" name="TextBox 2"/>
+              <a:t>Every one of 900 tiles scored exactly once by a model that never saw it</a:t>
+            </a:r>
+          </a:p>
+        </p:txBody>
+      </p:sp>
+      <p:graphicFrame>
+        <p:nvGraphicFramePr>
+          <p:cNvPr id="3" name="Table 2"/>
+          <p:cNvGraphicFramePr>
+            <a:graphicFrameLocks noGrp="1"/>
+          </p:cNvGraphicFramePr>
+          <p:nvPr/>
+        </p:nvGraphicFramePr>
+        <p:xfrm>
+          <a:off x="457200" y="1325880"/>
+          <a:ext cx="11292840" cy="1371600"/>
+        </p:xfrm>
+        <a:graphic>
+          <a:graphicData uri="http://schemas.openxmlformats.org/drawingml/2006/table">
+            <a:tbl>
+              <a:tblPr firstRow="1" bandRow="1">
+                <a:tableStyleId>{5C22544A-7EE6-4342-B048-85BDC9FD1C3A}</a:tableStyleId>
+              </a:tblPr>
+              <a:tblGrid>
+                <a:gridCol w="1411605"/>
+                <a:gridCol w="1411605"/>
+                <a:gridCol w="1411605"/>
+                <a:gridCol w="1411605"/>
+                <a:gridCol w="1411605"/>
+                <a:gridCol w="1411605"/>
+                <a:gridCol w="1411605"/>
+                <a:gridCol w="1411605"/>
+              </a:tblGrid>
+              <a:tr h="685800">
+                <a:tc>
+                  <a:txBody>
+                    <a:bodyPr/>
+                    <a:lstStyle/>
+                    <a:p>
+                      <a:pPr>
+                        <a:defRPr sz="1050" b="1">
+                          <a:solidFill>
+                            <a:srgbClr val="FFFFFF"/>
+                          </a:solidFill>
+                        </a:defRPr>
+                      </a:pPr>
+                      <a:r>
+                        <a:t>Hybrid</a:t>
+                      </a:r>
+                    </a:p>
+                  </a:txBody>
+                  <a:tcPr>
+                    <a:solidFill>
+                      <a:srgbClr val="0F233E"/>
+                    </a:solidFill>
+                  </a:tcPr>
+                </a:tc>
+                <a:tc>
+                  <a:txBody>
+                    <a:bodyPr/>
+                    <a:lstStyle/>
+                    <a:p>
+                      <a:pPr>
+                        <a:defRPr sz="1050" b="1">
+                          <a:solidFill>
+                            <a:srgbClr val="FFFFFF"/>
+                          </a:solidFill>
+                        </a:defRPr>
+                      </a:pPr>
+                      <a:r>
+                        <a:t>Params</a:t>
+                      </a:r>
+                    </a:p>
+                  </a:txBody>
+                  <a:tcPr>
+                    <a:solidFill>
+                      <a:srgbClr val="0F233E"/>
+                    </a:solidFill>
+                  </a:tcPr>
+                </a:tc>
+                <a:tc>
+                  <a:txBody>
+                    <a:bodyPr/>
+                    <a:lstStyle/>
+                    <a:p>
+                      <a:pPr>
+                        <a:defRPr sz="1050" b="1">
+                          <a:solidFill>
+                            <a:srgbClr val="FFFFFF"/>
+                          </a:solidFill>
+                        </a:defRPr>
+                      </a:pPr>
+                      <a:r>
+                        <a:t>OOF macro-F1</a:t>
+                      </a:r>
+                    </a:p>
+                  </a:txBody>
+                  <a:tcPr>
+                    <a:solidFill>
+                      <a:srgbClr val="0F233E"/>
+                    </a:solidFill>
+                  </a:tcPr>
+                </a:tc>
+                <a:tc>
+                  <a:txBody>
+                    <a:bodyPr/>
+                    <a:lstStyle/>
+                    <a:p>
+                      <a:pPr>
+                        <a:defRPr sz="1050" b="1">
+                          <a:solidFill>
+                            <a:srgbClr val="FFFFFF"/>
+                          </a:solidFill>
+                        </a:defRPr>
+                      </a:pPr>
+                      <a:r>
+                        <a:t>fold σ</a:t>
+                      </a:r>
+                    </a:p>
+                  </a:txBody>
+                  <a:tcPr>
+                    <a:solidFill>
+                      <a:srgbClr val="0F233E"/>
+                    </a:solidFill>
+                  </a:tcPr>
+                </a:tc>
+                <a:tc>
+                  <a:txBody>
+                    <a:bodyPr/>
+                    <a:lstStyle/>
+                    <a:p>
+                      <a:pPr>
+                        <a:defRPr sz="1050" b="1">
+                          <a:solidFill>
+                            <a:srgbClr val="FFFFFF"/>
+                          </a:solidFill>
+                        </a:defRPr>
+                      </a:pPr>
+                      <a:r>
+                        <a:t>Accuracy</a:t>
+                      </a:r>
+                    </a:p>
+                  </a:txBody>
+                  <a:tcPr>
+                    <a:solidFill>
+                      <a:srgbClr val="0F233E"/>
+                    </a:solidFill>
+                  </a:tcPr>
+                </a:tc>
+                <a:tc>
+                  <a:txBody>
+                    <a:bodyPr/>
+                    <a:lstStyle/>
+                    <a:p>
+                      <a:pPr>
+                        <a:defRPr sz="1050" b="1">
+                          <a:solidFill>
+                            <a:srgbClr val="FFFFFF"/>
+                          </a:solidFill>
+                        </a:defRPr>
+                      </a:pPr>
+                      <a:r>
+                        <a:t>Cohen's κ</a:t>
+                      </a:r>
+                    </a:p>
+                  </a:txBody>
+                  <a:tcPr>
+                    <a:solidFill>
+                      <a:srgbClr val="0F233E"/>
+                    </a:solidFill>
+                  </a:tcPr>
+                </a:tc>
+                <a:tc>
+                  <a:txBody>
+                    <a:bodyPr/>
+                    <a:lstStyle/>
+                    <a:p>
+                      <a:pPr>
+                        <a:defRPr sz="1050" b="1">
+                          <a:solidFill>
+                            <a:srgbClr val="FFFFFF"/>
+                          </a:solidFill>
+                        </a:defRPr>
+                      </a:pPr>
+                      <a:r>
+                        <a:t>Flood IoU</a:t>
+                      </a:r>
+                    </a:p>
+                  </a:txBody>
+                  <a:tcPr>
+                    <a:solidFill>
+                      <a:srgbClr val="0F233E"/>
+                    </a:solidFill>
+                  </a:tcPr>
+                </a:tc>
+                <a:tc>
+                  <a:txBody>
+                    <a:bodyPr/>
+                    <a:lstStyle/>
+                    <a:p>
+                      <a:pPr>
+                        <a:defRPr sz="1050" b="1">
+                          <a:solidFill>
+                            <a:srgbClr val="FFFFFF"/>
+                          </a:solidFill>
+                        </a:defRPr>
+                      </a:pPr>
+                      <a:r>
+                        <a:t>Train-val gap</a:t>
+                      </a:r>
+                    </a:p>
+                  </a:txBody>
+                  <a:tcPr>
+                    <a:solidFill>
+                      <a:srgbClr val="0F233E"/>
+                    </a:solidFill>
+                  </a:tcPr>
+                </a:tc>
+              </a:tr>
+              <a:tr h="685800">
+                <a:tc>
+                  <a:txBody>
+                    <a:bodyPr/>
+                    <a:lstStyle/>
+                    <a:p>
+                      <a:pPr>
+                        <a:defRPr sz="1050">
+                          <a:solidFill>
+                            <a:srgbClr val="0F233E"/>
+                          </a:solidFill>
+                        </a:defRPr>
+                      </a:pPr>
+                      <a:r>
+                        <a:t>YOLO12 + U-Net</a:t>
+                      </a:r>
+                    </a:p>
+                  </a:txBody>
+                  <a:tcPr/>
+                </a:tc>
+                <a:tc>
+                  <a:txBody>
+                    <a:bodyPr/>
+                    <a:lstStyle/>
+                    <a:p>
+                      <a:pPr>
+                        <a:defRPr sz="1050">
+                          <a:solidFill>
+                            <a:srgbClr val="0F233E"/>
+                          </a:solidFill>
+                        </a:defRPr>
+                      </a:pPr>
+                      <a:r>
+                        <a:t>5.5M</a:t>
+                      </a:r>
+                    </a:p>
+                  </a:txBody>
+                  <a:tcPr/>
+                </a:tc>
+                <a:tc>
+                  <a:txBody>
+                    <a:bodyPr/>
+                    <a:lstStyle/>
+                    <a:p>
+                      <a:pPr>
+                        <a:defRPr sz="1050">
+                          <a:solidFill>
+                            <a:srgbClr val="0F233E"/>
+                          </a:solidFill>
+                        </a:defRPr>
+                      </a:pPr>
+                      <a:r>
+                        <a:t>0.462</a:t>
+                      </a:r>
+                    </a:p>
+                  </a:txBody>
+                  <a:tcPr/>
+                </a:tc>
+                <a:tc>
+                  <a:txBody>
+                    <a:bodyPr/>
+                    <a:lstStyle/>
+                    <a:p>
+                      <a:pPr>
+                        <a:defRPr sz="1050">
+                          <a:solidFill>
+                            <a:srgbClr val="0F233E"/>
+                          </a:solidFill>
+                        </a:defRPr>
+                      </a:pPr>
+                      <a:r>
+                        <a:t>±0.048</a:t>
+                      </a:r>
+                    </a:p>
+                  </a:txBody>
+                  <a:tcPr/>
+                </a:tc>
+                <a:tc>
+                  <a:txBody>
+                    <a:bodyPr/>
+                    <a:lstStyle/>
+                    <a:p>
+                      <a:pPr>
+                        <a:defRPr sz="1050">
+                          <a:solidFill>
+                            <a:srgbClr val="0F233E"/>
+                          </a:solidFill>
+                        </a:defRPr>
+                      </a:pPr>
+                      <a:r>
+                        <a:t>0.713</a:t>
+                      </a:r>
+                    </a:p>
+                  </a:txBody>
+                  <a:tcPr/>
+                </a:tc>
+                <a:tc>
+                  <a:txBody>
+                    <a:bodyPr/>
+                    <a:lstStyle/>
+                    <a:p>
+                      <a:pPr>
+                        <a:defRPr sz="1050">
+                          <a:solidFill>
+                            <a:srgbClr val="0F233E"/>
+                          </a:solidFill>
+                        </a:defRPr>
+                      </a:pPr>
+                      <a:r>
+                        <a:t>0.388</a:t>
+                      </a:r>
+                    </a:p>
+                  </a:txBody>
+                  <a:tcPr/>
+                </a:tc>
+                <a:tc>
+                  <a:txBody>
+                    <a:bodyPr/>
+                    <a:lstStyle/>
+                    <a:p>
+                      <a:pPr>
+                        <a:defRPr sz="1050">
+                          <a:solidFill>
+                            <a:srgbClr val="0F233E"/>
+                          </a:solidFill>
+                        </a:defRPr>
+                      </a:pPr>
+                      <a:r>
+                        <a:t>0.205</a:t>
+                      </a:r>
+                    </a:p>
+                  </a:txBody>
+                  <a:tcPr/>
+                </a:tc>
+                <a:tc>
+                  <a:txBody>
+                    <a:bodyPr/>
+                    <a:lstStyle/>
+                    <a:p>
+                      <a:pPr>
+                        <a:defRPr sz="1050">
+                          <a:solidFill>
+                            <a:srgbClr val="0F233E"/>
+                          </a:solidFill>
+                        </a:defRPr>
+                      </a:pPr>
+                      <a:r>
+                        <a:t>-0.076 ✅</a:t>
+                      </a:r>
+                    </a:p>
+                  </a:txBody>
+                  <a:tcPr/>
+                </a:tc>
+              </a:tr>
+            </a:tbl>
+          </a:graphicData>
+        </a:graphic>
+      </p:graphicFrame>
+      <p:sp>
+        <p:nvSpPr>
+          <p:cNvPr id="4" name="TextBox 3"/>
           <p:cNvSpPr txBox="1"/>
           <p:nvPr/>
         </p:nvSpPr>
         <p:spPr>
           <a:xfrm>
-            <a:off x="640080" y="1417320"/>
-            <a:ext cx="10972800" cy="4846320"/>
+            <a:off x="457200" y="2788920"/>
+            <a:ext cx="11292840" cy="548640"/>
           </a:xfrm>
           <a:prstGeom prst="rect">
             <a:avLst/>
@@ -3384,92 +4328,292 @@
           <a:lstStyle/>
           <a:p>
             <a:pPr>
-              <a:spcAft>
-                <a:spcPts val="1000"/>
-              </a:spcAft>
-              <a:defRPr sz="1400">
-                <a:solidFill>
-                  <a:srgbClr val="0F233E"/>
-                </a:solidFill>
-              </a:defRPr>
-            </a:pPr>
-            <a:r>
-              <a:t>• Select or upload a SAR tile → predicted damage mask overlaid on the backscatter image</a:t>
-            </a:r>
-          </a:p>
-          <a:p>
-            <a:pPr>
-              <a:spcAft>
-                <a:spcPts val="1000"/>
-              </a:spcAft>
-              <a:defRPr sz="1400">
-                <a:solidFill>
-                  <a:srgbClr val="0F233E"/>
-                </a:solidFill>
-              </a:defRPr>
-            </a:pPr>
-            <a:r>
-              <a:t>• Severity with confidence, net inundated fraction, permanent water shown separately</a:t>
-            </a:r>
-          </a:p>
-          <a:p>
-            <a:pPr>
-              <a:spcAft>
-                <a:spcPts val="1000"/>
-              </a:spcAft>
-              <a:defRPr sz="1400">
-                <a:solidFill>
-                  <a:srgbClr val="0F233E"/>
-                </a:solidFill>
-              </a:defRPr>
-            </a:pPr>
-            <a:r>
-              <a:t>• District loss estimate: affected hectares, production loss in tonnes, indicative value in ₹ crore</a:t>
-            </a:r>
-          </a:p>
-          <a:p>
-            <a:pPr>
-              <a:spcAft>
-                <a:spcPts val="1000"/>
-              </a:spcAft>
-              <a:defRPr sz="1400">
-                <a:solidFill>
-                  <a:srgbClr val="0F233E"/>
-                </a:solidFill>
-              </a:defRPr>
-            </a:pPr>
-            <a:r>
-              <a:t>• Fusion panel showing whether imagery and district history agree, and whether severity was escalated</a:t>
-            </a:r>
-          </a:p>
-          <a:p>
-            <a:pPr>
-              <a:spcAft>
-                <a:spcPts val="1000"/>
-              </a:spcAft>
-              <a:defRPr sz="1400">
-                <a:solidFill>
-                  <a:srgbClr val="0F233E"/>
-                </a:solidFill>
-              </a:defRPr>
-            </a:pPr>
-            <a:r>
-              <a:t>• </a:t>
-            </a:r>
-          </a:p>
-          <a:p>
-            <a:pPr>
-              <a:spcAft>
-                <a:spcPts val="1000"/>
-              </a:spcAft>
-              <a:defRPr sz="1400">
-                <a:solidFill>
-                  <a:srgbClr val="0F233E"/>
-                </a:solidFill>
-              </a:defRPr>
-            </a:pPr>
-            <a:r>
-              <a:t>• Runs with or without a trained checkpoint — the rule-based path still demonstrates preprocessing, the severity rule and the fusion arithmetic</a:t>
+              <a:defRPr sz="1100">
+                <a:solidFill>
+                  <a:srgbClr val="475569"/>
+                </a:solidFill>
+              </a:defRPr>
+            </a:pPr>
+            <a:r>
+              <a:t>Train-val gap is the anti-overfitting check: ≤ 0.10 is healthy, and negative means validation scored above training. The five-model baseline ran at +0.19 to +0.35.</a:t>
+            </a:r>
+          </a:p>
+        </p:txBody>
+      </p:sp>
+      <p:graphicFrame>
+        <p:nvGraphicFramePr>
+          <p:cNvPr id="5" name="Table 4"/>
+          <p:cNvGraphicFramePr>
+            <a:graphicFrameLocks noGrp="1"/>
+          </p:cNvGraphicFramePr>
+          <p:nvPr/>
+        </p:nvGraphicFramePr>
+        <p:xfrm>
+          <a:off x="457200" y="3383280"/>
+          <a:ext cx="11292840" cy="1188720"/>
+        </p:xfrm>
+        <a:graphic>
+          <a:graphicData uri="http://schemas.openxmlformats.org/drawingml/2006/table">
+            <a:tbl>
+              <a:tblPr firstRow="1" bandRow="1">
+                <a:tableStyleId>{5C22544A-7EE6-4342-B048-85BDC9FD1C3A}</a:tableStyleId>
+              </a:tblPr>
+              <a:tblGrid>
+                <a:gridCol w="2258568"/>
+                <a:gridCol w="2258568"/>
+                <a:gridCol w="2258568"/>
+                <a:gridCol w="2258568"/>
+                <a:gridCol w="2258568"/>
+              </a:tblGrid>
+              <a:tr h="594360">
+                <a:tc>
+                  <a:txBody>
+                    <a:bodyPr/>
+                    <a:lstStyle/>
+                    <a:p>
+                      <a:pPr>
+                        <a:defRPr sz="1050" b="1">
+                          <a:solidFill>
+                            <a:srgbClr val="FFFFFF"/>
+                          </a:solidFill>
+                        </a:defRPr>
+                      </a:pPr>
+                      <a:r>
+                        <a:t>Hybrid</a:t>
+                      </a:r>
+                    </a:p>
+                  </a:txBody>
+                  <a:tcPr>
+                    <a:solidFill>
+                      <a:srgbClr val="0F233E"/>
+                    </a:solidFill>
+                  </a:tcPr>
+                </a:tc>
+                <a:tc>
+                  <a:txBody>
+                    <a:bodyPr/>
+                    <a:lstStyle/>
+                    <a:p>
+                      <a:pPr>
+                        <a:defRPr sz="1050" b="1">
+                          <a:solidFill>
+                            <a:srgbClr val="FFFFFF"/>
+                          </a:solidFill>
+                        </a:defRPr>
+                      </a:pPr>
+                      <a:r>
+                        <a:t>Within-1-class accuracy</a:t>
+                      </a:r>
+                    </a:p>
+                  </a:txBody>
+                  <a:tcPr>
+                    <a:solidFill>
+                      <a:srgbClr val="0F233E"/>
+                    </a:solidFill>
+                  </a:tcPr>
+                </a:tc>
+                <a:tc>
+                  <a:txBody>
+                    <a:bodyPr/>
+                    <a:lstStyle/>
+                    <a:p>
+                      <a:pPr>
+                        <a:defRPr sz="1050" b="1">
+                          <a:solidFill>
+                            <a:srgbClr val="FFFFFF"/>
+                          </a:solidFill>
+                        </a:defRPr>
+                      </a:pPr>
+                      <a:r>
+                        <a:t>Ordinal MAE</a:t>
+                      </a:r>
+                    </a:p>
+                  </a:txBody>
+                  <a:tcPr>
+                    <a:solidFill>
+                      <a:srgbClr val="0F233E"/>
+                    </a:solidFill>
+                  </a:tcPr>
+                </a:tc>
+                <a:tc>
+                  <a:txBody>
+                    <a:bodyPr/>
+                    <a:lstStyle/>
+                    <a:p>
+                      <a:pPr>
+                        <a:defRPr sz="1050" b="1">
+                          <a:solidFill>
+                            <a:srgbClr val="FFFFFF"/>
+                          </a:solidFill>
+                        </a:defRPr>
+                      </a:pPr>
+                      <a:r>
+                        <a:t>Binary damage accuracy</a:t>
+                      </a:r>
+                    </a:p>
+                  </a:txBody>
+                  <a:tcPr>
+                    <a:solidFill>
+                      <a:srgbClr val="0F233E"/>
+                    </a:solidFill>
+                  </a:tcPr>
+                </a:tc>
+                <a:tc>
+                  <a:txBody>
+                    <a:bodyPr/>
+                    <a:lstStyle/>
+                    <a:p>
+                      <a:pPr>
+                        <a:defRPr sz="1050" b="1">
+                          <a:solidFill>
+                            <a:srgbClr val="FFFFFF"/>
+                          </a:solidFill>
+                        </a:defRPr>
+                      </a:pPr>
+                      <a:r>
+                        <a:t>Binary damage F1</a:t>
+                      </a:r>
+                    </a:p>
+                  </a:txBody>
+                  <a:tcPr>
+                    <a:solidFill>
+                      <a:srgbClr val="0F233E"/>
+                    </a:solidFill>
+                  </a:tcPr>
+                </a:tc>
+              </a:tr>
+              <a:tr h="594360">
+                <a:tc>
+                  <a:txBody>
+                    <a:bodyPr/>
+                    <a:lstStyle/>
+                    <a:p>
+                      <a:pPr>
+                        <a:defRPr sz="1050">
+                          <a:solidFill>
+                            <a:srgbClr val="0F233E"/>
+                          </a:solidFill>
+                        </a:defRPr>
+                      </a:pPr>
+                      <a:r>
+                        <a:t>YOLO12 + U-Net</a:t>
+                      </a:r>
+                    </a:p>
+                  </a:txBody>
+                  <a:tcPr/>
+                </a:tc>
+                <a:tc>
+                  <a:txBody>
+                    <a:bodyPr/>
+                    <a:lstStyle/>
+                    <a:p>
+                      <a:pPr>
+                        <a:defRPr sz="1050">
+                          <a:solidFill>
+                            <a:srgbClr val="0F233E"/>
+                          </a:solidFill>
+                        </a:defRPr>
+                      </a:pPr>
+                      <a:r>
+                        <a:t>0.951</a:t>
+                      </a:r>
+                    </a:p>
+                  </a:txBody>
+                  <a:tcPr/>
+                </a:tc>
+                <a:tc>
+                  <a:txBody>
+                    <a:bodyPr/>
+                    <a:lstStyle/>
+                    <a:p>
+                      <a:pPr>
+                        <a:defRPr sz="1050">
+                          <a:solidFill>
+                            <a:srgbClr val="0F233E"/>
+                          </a:solidFill>
+                        </a:defRPr>
+                      </a:pPr>
+                      <a:r>
+                        <a:t>0.338</a:t>
+                      </a:r>
+                    </a:p>
+                  </a:txBody>
+                  <a:tcPr/>
+                </a:tc>
+                <a:tc>
+                  <a:txBody>
+                    <a:bodyPr/>
+                    <a:lstStyle/>
+                    <a:p>
+                      <a:pPr>
+                        <a:defRPr sz="1050">
+                          <a:solidFill>
+                            <a:srgbClr val="0F233E"/>
+                          </a:solidFill>
+                        </a:defRPr>
+                      </a:pPr>
+                      <a:r>
+                        <a:t>0.798</a:t>
+                      </a:r>
+                    </a:p>
+                  </a:txBody>
+                  <a:tcPr/>
+                </a:tc>
+                <a:tc>
+                  <a:txBody>
+                    <a:bodyPr/>
+                    <a:lstStyle/>
+                    <a:p>
+                      <a:pPr>
+                        <a:defRPr sz="1050">
+                          <a:solidFill>
+                            <a:srgbClr val="0F233E"/>
+                          </a:solidFill>
+                        </a:defRPr>
+                      </a:pPr>
+                      <a:r>
+                        <a:t>0.664</a:t>
+                      </a:r>
+                    </a:p>
+                  </a:txBody>
+                  <a:tcPr/>
+                </a:tc>
+              </a:tr>
+            </a:tbl>
+          </a:graphicData>
+        </a:graphic>
+      </p:graphicFrame>
+      <p:sp>
+        <p:nvSpPr>
+          <p:cNvPr id="6" name="TextBox 5"/>
+          <p:cNvSpPr txBox="1"/>
+          <p:nvPr/>
+        </p:nvSpPr>
+        <p:spPr>
+          <a:xfrm>
+            <a:off x="457200" y="4709160"/>
+            <a:ext cx="11292840" cy="1737360"/>
+          </a:xfrm>
+          <a:prstGeom prst="rect">
+            <a:avLst/>
+          </a:prstGeom>
+          <a:noFill/>
+        </p:spPr>
+        <p:txBody>
+          <a:bodyPr wrap="square">
+            <a:spAutoFit/>
+          </a:bodyPr>
+          <a:lstStyle/>
+          <a:p>
+            <a:pPr>
+              <a:defRPr sz="1150">
+                <a:solidFill>
+                  <a:srgbClr val="475569"/>
+                </a:solidFill>
+              </a:defRPr>
+            </a:pPr>
+            <a:r>
+              <a:t>Supplementary, not a replacement. Macro-F1 treats the four classes as unrelated, so calling a Severe tile Moderate scores as badly as calling it Healthy — and every Severe miss in our confusion matrices lands on Moderate, the adjacent class.</a:t>
             </a:r>
           </a:p>
         </p:txBody>
@@ -3522,7 +4666,7 @@
               </a:defRPr>
             </a:pPr>
             <a:r>
-              <a:t>Honest limitations</a:t>
+              <a:t>Confidence calibration</a:t>
             </a:r>
           </a:p>
           <a:p>
@@ -3534,20 +4678,306 @@
               </a:defRPr>
             </a:pPr>
             <a:r>
-              <a:t>Stated because they are the questions worth asking</a:t>
-            </a:r>
-          </a:p>
-        </p:txBody>
-      </p:sp>
-      <p:sp>
-        <p:nvSpPr>
-          <p:cNvPr id="3" name="TextBox 2"/>
+              <a:t>Temperature scaling, fitted on inner folds only</a:t>
+            </a:r>
+          </a:p>
+        </p:txBody>
+      </p:sp>
+      <p:graphicFrame>
+        <p:nvGraphicFramePr>
+          <p:cNvPr id="3" name="Table 2"/>
+          <p:cNvGraphicFramePr>
+            <a:graphicFrameLocks noGrp="1"/>
+          </p:cNvGraphicFramePr>
+          <p:nvPr/>
+        </p:nvGraphicFramePr>
+        <p:xfrm>
+          <a:off x="548640" y="1371600"/>
+          <a:ext cx="11064240" cy="1280160"/>
+        </p:xfrm>
+        <a:graphic>
+          <a:graphicData uri="http://schemas.openxmlformats.org/drawingml/2006/table">
+            <a:tbl>
+              <a:tblPr firstRow="1" bandRow="1">
+                <a:tableStyleId>{5C22544A-7EE6-4342-B048-85BDC9FD1C3A}</a:tableStyleId>
+              </a:tblPr>
+              <a:tblGrid>
+                <a:gridCol w="1844040"/>
+                <a:gridCol w="1844040"/>
+                <a:gridCol w="1844040"/>
+                <a:gridCol w="1844040"/>
+                <a:gridCol w="1844040"/>
+                <a:gridCol w="1844040"/>
+              </a:tblGrid>
+              <a:tr h="640080">
+                <a:tc>
+                  <a:txBody>
+                    <a:bodyPr/>
+                    <a:lstStyle/>
+                    <a:p>
+                      <a:pPr>
+                        <a:defRPr sz="1100" b="1">
+                          <a:solidFill>
+                            <a:srgbClr val="FFFFFF"/>
+                          </a:solidFill>
+                        </a:defRPr>
+                      </a:pPr>
+                      <a:r>
+                        <a:t>Hybrid</a:t>
+                      </a:r>
+                    </a:p>
+                  </a:txBody>
+                  <a:tcPr>
+                    <a:solidFill>
+                      <a:srgbClr val="0F233E"/>
+                    </a:solidFill>
+                  </a:tcPr>
+                </a:tc>
+                <a:tc>
+                  <a:txBody>
+                    <a:bodyPr/>
+                    <a:lstStyle/>
+                    <a:p>
+                      <a:pPr>
+                        <a:defRPr sz="1100" b="1">
+                          <a:solidFill>
+                            <a:srgbClr val="FFFFFF"/>
+                          </a:solidFill>
+                        </a:defRPr>
+                      </a:pPr>
+                      <a:r>
+                        <a:t>Temperature</a:t>
+                      </a:r>
+                    </a:p>
+                  </a:txBody>
+                  <a:tcPr>
+                    <a:solidFill>
+                      <a:srgbClr val="0F233E"/>
+                    </a:solidFill>
+                  </a:tcPr>
+                </a:tc>
+                <a:tc>
+                  <a:txBody>
+                    <a:bodyPr/>
+                    <a:lstStyle/>
+                    <a:p>
+                      <a:pPr>
+                        <a:defRPr sz="1100" b="1">
+                          <a:solidFill>
+                            <a:srgbClr val="FFFFFF"/>
+                          </a:solidFill>
+                        </a:defRPr>
+                      </a:pPr>
+                      <a:r>
+                        <a:t>ECE before</a:t>
+                      </a:r>
+                    </a:p>
+                  </a:txBody>
+                  <a:tcPr>
+                    <a:solidFill>
+                      <a:srgbClr val="0F233E"/>
+                    </a:solidFill>
+                  </a:tcPr>
+                </a:tc>
+                <a:tc>
+                  <a:txBody>
+                    <a:bodyPr/>
+                    <a:lstStyle/>
+                    <a:p>
+                      <a:pPr>
+                        <a:defRPr sz="1100" b="1">
+                          <a:solidFill>
+                            <a:srgbClr val="FFFFFF"/>
+                          </a:solidFill>
+                        </a:defRPr>
+                      </a:pPr>
+                      <a:r>
+                        <a:t>ECE after</a:t>
+                      </a:r>
+                    </a:p>
+                  </a:txBody>
+                  <a:tcPr>
+                    <a:solidFill>
+                      <a:srgbClr val="0F233E"/>
+                    </a:solidFill>
+                  </a:tcPr>
+                </a:tc>
+                <a:tc>
+                  <a:txBody>
+                    <a:bodyPr/>
+                    <a:lstStyle/>
+                    <a:p>
+                      <a:pPr>
+                        <a:defRPr sz="1100" b="1">
+                          <a:solidFill>
+                            <a:srgbClr val="FFFFFF"/>
+                          </a:solidFill>
+                        </a:defRPr>
+                      </a:pPr>
+                      <a:r>
+                        <a:t>Mean confidence before → after</a:t>
+                      </a:r>
+                    </a:p>
+                  </a:txBody>
+                  <a:tcPr>
+                    <a:solidFill>
+                      <a:srgbClr val="0F233E"/>
+                    </a:solidFill>
+                  </a:tcPr>
+                </a:tc>
+                <a:tc>
+                  <a:txBody>
+                    <a:bodyPr/>
+                    <a:lstStyle/>
+                    <a:p>
+                      <a:pPr>
+                        <a:defRPr sz="1100" b="1">
+                          <a:solidFill>
+                            <a:srgbClr val="FFFFFF"/>
+                          </a:solidFill>
+                        </a:defRPr>
+                      </a:pPr>
+                      <a:r>
+                        <a:t>Folds accepted</a:t>
+                      </a:r>
+                    </a:p>
+                  </a:txBody>
+                  <a:tcPr>
+                    <a:solidFill>
+                      <a:srgbClr val="0F233E"/>
+                    </a:solidFill>
+                  </a:tcPr>
+                </a:tc>
+              </a:tr>
+              <a:tr h="640080">
+                <a:tc>
+                  <a:txBody>
+                    <a:bodyPr/>
+                    <a:lstStyle/>
+                    <a:p>
+                      <a:pPr>
+                        <a:defRPr sz="1100">
+                          <a:solidFill>
+                            <a:srgbClr val="0F233E"/>
+                          </a:solidFill>
+                        </a:defRPr>
+                      </a:pPr>
+                      <a:r>
+                        <a:t>YOLO12 + U-Net</a:t>
+                      </a:r>
+                    </a:p>
+                  </a:txBody>
+                  <a:tcPr/>
+                </a:tc>
+                <a:tc>
+                  <a:txBody>
+                    <a:bodyPr/>
+                    <a:lstStyle/>
+                    <a:p>
+                      <a:pPr>
+                        <a:defRPr sz="1100">
+                          <a:solidFill>
+                            <a:srgbClr val="0F233E"/>
+                          </a:solidFill>
+                        </a:defRPr>
+                      </a:pPr>
+                      <a:r>
+                        <a:t>0.476</a:t>
+                      </a:r>
+                    </a:p>
+                  </a:txBody>
+                  <a:tcPr/>
+                </a:tc>
+                <a:tc>
+                  <a:txBody>
+                    <a:bodyPr/>
+                    <a:lstStyle/>
+                    <a:p>
+                      <a:pPr>
+                        <a:defRPr sz="1100">
+                          <a:solidFill>
+                            <a:srgbClr val="0F233E"/>
+                          </a:solidFill>
+                        </a:defRPr>
+                      </a:pPr>
+                      <a:r>
+                        <a:t>0.163</a:t>
+                      </a:r>
+                    </a:p>
+                  </a:txBody>
+                  <a:tcPr/>
+                </a:tc>
+                <a:tc>
+                  <a:txBody>
+                    <a:bodyPr/>
+                    <a:lstStyle/>
+                    <a:p>
+                      <a:pPr>
+                        <a:defRPr sz="1100">
+                          <a:solidFill>
+                            <a:srgbClr val="0F233E"/>
+                          </a:solidFill>
+                        </a:defRPr>
+                      </a:pPr>
+                      <a:r>
+                        <a:t>0.078</a:t>
+                      </a:r>
+                    </a:p>
+                  </a:txBody>
+                  <a:tcPr/>
+                </a:tc>
+                <a:tc>
+                  <a:txBody>
+                    <a:bodyPr/>
+                    <a:lstStyle/>
+                    <a:p>
+                      <a:pPr>
+                        <a:defRPr sz="1100">
+                          <a:solidFill>
+                            <a:srgbClr val="0F233E"/>
+                          </a:solidFill>
+                        </a:defRPr>
+                      </a:pPr>
+                      <a:r>
+                        <a:t>61.0% → 76.9%</a:t>
+                      </a:r>
+                    </a:p>
+                  </a:txBody>
+                  <a:tcPr/>
+                </a:tc>
+                <a:tc>
+                  <a:txBody>
+                    <a:bodyPr/>
+                    <a:lstStyle/>
+                    <a:p>
+                      <a:pPr>
+                        <a:defRPr sz="1100">
+                          <a:solidFill>
+                            <a:srgbClr val="0F233E"/>
+                          </a:solidFill>
+                        </a:defRPr>
+                      </a:pPr>
+                      <a:r>
+                        <a:t>5/5</a:t>
+                      </a:r>
+                    </a:p>
+                  </a:txBody>
+                  <a:tcPr/>
+                </a:tc>
+              </a:tr>
+            </a:tbl>
+          </a:graphicData>
+        </a:graphic>
+      </p:graphicFrame>
+      <p:sp>
+        <p:nvSpPr>
+          <p:cNvPr id="4" name="TextBox 3"/>
           <p:cNvSpPr txBox="1"/>
           <p:nvPr/>
         </p:nvSpPr>
         <p:spPr>
           <a:xfrm>
-            <a:off x="640080" y="1417320"/>
+            <a:off x="640080" y="2926080"/>
             <a:ext cx="10972800" cy="4846320"/>
           </a:xfrm>
           <a:prstGeom prst="rect">
@@ -3563,7 +4993,7 @@
           <a:p>
             <a:pPr>
               <a:spcAft>
-                <a:spcPts val="1300"/>
+                <a:spcPts val="1100"/>
               </a:spcAft>
               <a:defRPr sz="1300">
                 <a:solidFill>
@@ -3572,13 +5002,13 @@
               </a:defRPr>
             </a:pPr>
             <a:r>
-              <a:t>• Severity is derived from flood extent, not measured agronomic damage — ETCI-2021 has flood masks, not crop-damage ground truth. Validation against field-surveyed loss is NOT claimed.</a:t>
+              <a:t>• An uncalibrated softmax is a score that sums to one, not a probability.</a:t>
             </a:r>
           </a:p>
           <a:p>
             <a:pPr>
               <a:spcAft>
-                <a:spcPts val="1300"/>
+                <a:spcPts val="1100"/>
               </a:spcAft>
               <a:defRPr sz="1300">
                 <a:solidFill>
@@ -3587,13 +5017,13 @@
               </a:defRPr>
             </a:pPr>
             <a:r>
-              <a:t>• Only 20 Severe tiles exist in the whole pool (0.98% natural prior), so Severe-class F1 is noisy by construction. This is the corpus ceiling and is what GAN augmentation pushes against.</a:t>
+              <a:t>• Temperature scaling divides the logits by one learned scalar — it is argmax-invariant, so it cannot change accuracy, only how honest the confidence is.</a:t>
             </a:r>
           </a:p>
           <a:p>
             <a:pPr>
               <a:spcAft>
-                <a:spcPts val="1300"/>
+                <a:spcPts val="1100"/>
               </a:spcAft>
               <a:defRPr sz="1300">
                 <a:solidFill>
@@ -3602,13 +5032,13 @@
               </a:defRPr>
             </a:pPr>
             <a:r>
-              <a:t>• Tiers cap Healthy at 45% to make the benchmark usable; the natural 86.9% prior is reported alongside every result, not hidden.</a:t>
+              <a:t>• Fitted on an inner validation slice of each training fold, never on the held-out fold.</a:t>
             </a:r>
           </a:p>
           <a:p>
             <a:pPr>
               <a:spcAft>
-                <a:spcPts val="1300"/>
+                <a:spcPts val="1100"/>
               </a:spcAft>
               <a:defRPr sz="1300">
                 <a:solidFill>
@@ -3617,13 +5047,13 @@
               </a:defRPr>
             </a:pPr>
             <a:r>
-              <a:t>• Training geography is the Ganges–Brahmaputra delta — a reasonable analogue for eastern India, but cross-region transfer is untested. FLNet states the same limitation about itself.</a:t>
+              <a:t>• A fold's fit is accepted only if it cuts calibration error by at least 20%; otherwise the temperature resets to 1.0 and nothing is applied.</a:t>
             </a:r>
           </a:p>
           <a:p>
             <a:pPr>
               <a:spcAft>
-                <a:spcPts val="1300"/>
+                <a:spcPts val="1100"/>
               </a:spcAft>
               <a:defRPr sz="1300">
                 <a:solidFill>
@@ -3632,7 +5062,7 @@
               </a:defRPr>
             </a:pPr>
             <a:r>
-              <a:t>• Rupee figures use assumed per-severity loss coefficients, surfaced as parameters rather than fitted values.</a:t>
+              <a:t>• Paper 4 of our review names temperature scaling as its first future-work item.</a:t>
             </a:r>
           </a:p>
         </p:txBody>
@@ -3685,7 +5115,96 @@
               </a:defRPr>
             </a:pPr>
             <a:r>
-              <a:t>What remains — the other 40%</a:t>
+              <a:t>Predictions across severity classes</a:t>
+            </a:r>
+          </a:p>
+        </p:txBody>
+      </p:sp>
+      <p:pic>
+        <p:nvPicPr>
+          <p:cNvPr id="3" name="Picture 2" descr="predictions.png"/>
+          <p:cNvPicPr>
+            <a:picLocks noChangeAspect="1"/>
+          </p:cNvPicPr>
+          <p:nvPr/>
+        </p:nvPicPr>
+        <p:blipFill>
+          <a:blip r:embed="rId2"/>
+          <a:stretch>
+            <a:fillRect/>
+          </a:stretch>
+        </p:blipFill>
+        <p:spPr>
+          <a:xfrm>
+            <a:off x="640080" y="1463040"/>
+            <a:ext cx="10881360" cy="10211738"/>
+          </a:xfrm>
+          <a:prstGeom prst="rect">
+            <a:avLst/>
+          </a:prstGeom>
+        </p:spPr>
+      </p:pic>
+    </p:spTree>
+  </p:cSld>
+  <p:clrMapOvr>
+    <a:masterClrMapping/>
+  </p:clrMapOvr>
+</p:sld>
+</file>
+
+<file path=ppt/slides/slide14.xml><?xml version="1.0" encoding="utf-8"?>
+<p:sld xmlns:a="http://schemas.openxmlformats.org/drawingml/2006/main" xmlns:p="http://schemas.openxmlformats.org/presentationml/2006/main" xmlns:r="http://schemas.openxmlformats.org/officeDocument/2006/relationships">
+  <p:cSld>
+    <p:spTree>
+      <p:nvGrpSpPr>
+        <p:cNvPr id="1" name=""/>
+        <p:cNvGrpSpPr/>
+        <p:nvPr/>
+      </p:nvGrpSpPr>
+      <p:grpSpPr/>
+      <p:sp>
+        <p:nvSpPr>
+          <p:cNvPr id="2" name="TextBox 1"/>
+          <p:cNvSpPr txBox="1"/>
+          <p:nvPr/>
+        </p:nvSpPr>
+        <p:spPr>
+          <a:xfrm>
+            <a:off x="502920" y="310896"/>
+            <a:ext cx="11155680" cy="777240"/>
+          </a:xfrm>
+          <a:prstGeom prst="rect">
+            <a:avLst/>
+          </a:prstGeom>
+          <a:noFill/>
+        </p:spPr>
+        <p:txBody>
+          <a:bodyPr wrap="none">
+            <a:spAutoFit/>
+          </a:bodyPr>
+          <a:lstStyle/>
+          <a:p>
+            <a:pPr>
+              <a:defRPr sz="3000" b="1">
+                <a:solidFill>
+                  <a:srgbClr val="0F233E"/>
+                </a:solidFill>
+              </a:defRPr>
+            </a:pPr>
+            <a:r>
+              <a:t>Working demo</a:t>
+            </a:r>
+          </a:p>
+          <a:p>
+            <a:pPr>
+              <a:defRPr sz="1300">
+                <a:solidFill>
+                  <a:srgbClr val="475569"/>
+                </a:solidFill>
+              </a:defRPr>
+            </a:pPr>
+            <a:r>
+              <a:t>streamlit run app/streamlit_app.py</a:t>
             </a:r>
           </a:p>
         </p:txBody>
@@ -3714,91 +5233,91 @@
           <a:p>
             <a:pPr>
               <a:spcAft>
-                <a:spcPts val="1300"/>
+                <a:spcPts val="1000"/>
               </a:spcAft>
-              <a:defRPr sz="1500">
+              <a:defRPr sz="1400">
                 <a:solidFill>
                   <a:srgbClr val="0F233E"/>
                 </a:solidFill>
               </a:defRPr>
             </a:pPr>
             <a:r>
-              <a:t>• Validation against field-surveyed crop loss (BFCD-22, or state revenue records)</a:t>
+              <a:t>• Select or upload a SAR tile → predicted damage mask overlaid on the backscatter image</a:t>
             </a:r>
           </a:p>
           <a:p>
             <a:pPr>
               <a:spcAft>
-                <a:spcPts val="1300"/>
+                <a:spcPts val="1000"/>
               </a:spcAft>
-              <a:defRPr sz="1500">
+              <a:defRPr sz="1400">
                 <a:solidFill>
                   <a:srgbClr val="0F233E"/>
                 </a:solidFill>
               </a:defRPr>
             </a:pPr>
             <a:r>
-              <a:t>• Cross-region transfer to Indian districts, and domain adaptation</a:t>
+              <a:t>• Severity with confidence, net inundated fraction, permanent water shown separately</a:t>
             </a:r>
           </a:p>
           <a:p>
             <a:pPr>
               <a:spcAft>
-                <a:spcPts val="1300"/>
+                <a:spcPts val="1000"/>
               </a:spcAft>
-              <a:defRPr sz="1500">
+              <a:defRPr sz="1400">
                 <a:solidFill>
                   <a:srgbClr val="0F233E"/>
                 </a:solidFill>
               </a:defRPr>
             </a:pPr>
             <a:r>
-              <a:t>• Sentinel-1 + Sentinel-2 fusion, as FLNet's future work proposes</a:t>
+              <a:t>• District loss estimate: affected hectares, production loss in tonnes, indicative value in ₹ crore</a:t>
             </a:r>
           </a:p>
           <a:p>
             <a:pPr>
               <a:spcAft>
-                <a:spcPts val="1300"/>
+                <a:spcPts val="1000"/>
               </a:spcAft>
-              <a:defRPr sz="1500">
+              <a:defRPr sz="1400">
                 <a:solidFill>
                   <a:srgbClr val="0F233E"/>
                 </a:solidFill>
               </a:defRPr>
             </a:pPr>
             <a:r>
-              <a:t>• Calibration and uncertainty estimates, as the Explainable SAR paper proposes</a:t>
+              <a:t>• Fusion panel showing whether imagery and district history agree, and whether severity was escalated</a:t>
             </a:r>
           </a:p>
           <a:p>
             <a:pPr>
               <a:spcAft>
-                <a:spcPts val="1300"/>
+                <a:spcPts val="1000"/>
               </a:spcAft>
-              <a:defRPr sz="1500">
+              <a:defRPr sz="1400">
                 <a:solidFill>
                   <a:srgbClr val="0F233E"/>
                 </a:solidFill>
               </a:defRPr>
             </a:pPr>
             <a:r>
-              <a:t>• 10-fold cross validation extended to the image pipeline once compute allows</a:t>
+              <a:t>• </a:t>
             </a:r>
           </a:p>
           <a:p>
             <a:pPr>
               <a:spcAft>
-                <a:spcPts val="1300"/>
+                <a:spcPts val="1000"/>
               </a:spcAft>
-              <a:defRPr sz="1500">
+              <a:defRPr sz="1400">
                 <a:solidFill>
                   <a:srgbClr val="0F233E"/>
                 </a:solidFill>
               </a:defRPr>
             </a:pPr>
             <a:r>
-              <a:t>• Higher tiers (T4) and longer schedules on stronger hardware</a:t>
+              <a:t>• Runs with or without a trained checkpoint — the rule-based path still demonstrates preprocessing, the severity rule and the fusion arithmetic</a:t>
             </a:r>
           </a:p>
         </p:txBody>
@@ -3811,7 +5330,366 @@
 </p:sld>
 </file>
 
-<file path=ppt/slides/slide14.xml><?xml version="1.0" encoding="utf-8"?>
+<file path=ppt/slides/slide15.xml><?xml version="1.0" encoding="utf-8"?>
+<p:sld xmlns:a="http://schemas.openxmlformats.org/drawingml/2006/main" xmlns:p="http://schemas.openxmlformats.org/presentationml/2006/main" xmlns:r="http://schemas.openxmlformats.org/officeDocument/2006/relationships">
+  <p:cSld>
+    <p:spTree>
+      <p:nvGrpSpPr>
+        <p:cNvPr id="1" name=""/>
+        <p:cNvGrpSpPr/>
+        <p:nvPr/>
+      </p:nvGrpSpPr>
+      <p:grpSpPr/>
+      <p:sp>
+        <p:nvSpPr>
+          <p:cNvPr id="2" name="TextBox 1"/>
+          <p:cNvSpPr txBox="1"/>
+          <p:nvPr/>
+        </p:nvSpPr>
+        <p:spPr>
+          <a:xfrm>
+            <a:off x="502920" y="310896"/>
+            <a:ext cx="11155680" cy="777240"/>
+          </a:xfrm>
+          <a:prstGeom prst="rect">
+            <a:avLst/>
+          </a:prstGeom>
+          <a:noFill/>
+        </p:spPr>
+        <p:txBody>
+          <a:bodyPr wrap="none">
+            <a:spAutoFit/>
+          </a:bodyPr>
+          <a:lstStyle/>
+          <a:p>
+            <a:pPr>
+              <a:defRPr sz="3000" b="1">
+                <a:solidFill>
+                  <a:srgbClr val="0F233E"/>
+                </a:solidFill>
+              </a:defRPr>
+            </a:pPr>
+            <a:r>
+              <a:t>Honest limitations</a:t>
+            </a:r>
+          </a:p>
+          <a:p>
+            <a:pPr>
+              <a:defRPr sz="1300">
+                <a:solidFill>
+                  <a:srgbClr val="475569"/>
+                </a:solidFill>
+              </a:defRPr>
+            </a:pPr>
+            <a:r>
+              <a:t>Stated because they are the questions worth asking</a:t>
+            </a:r>
+          </a:p>
+        </p:txBody>
+      </p:sp>
+      <p:sp>
+        <p:nvSpPr>
+          <p:cNvPr id="3" name="TextBox 2"/>
+          <p:cNvSpPr txBox="1"/>
+          <p:nvPr/>
+        </p:nvSpPr>
+        <p:spPr>
+          <a:xfrm>
+            <a:off x="640080" y="1417320"/>
+            <a:ext cx="10972800" cy="4846320"/>
+          </a:xfrm>
+          <a:prstGeom prst="rect">
+            <a:avLst/>
+          </a:prstGeom>
+          <a:noFill/>
+        </p:spPr>
+        <p:txBody>
+          <a:bodyPr wrap="square">
+            <a:spAutoFit/>
+          </a:bodyPr>
+          <a:lstStyle/>
+          <a:p>
+            <a:pPr>
+              <a:spcAft>
+                <a:spcPts val="900"/>
+              </a:spcAft>
+              <a:defRPr sz="1150">
+                <a:solidFill>
+                  <a:srgbClr val="0F233E"/>
+                </a:solidFill>
+              </a:defRPr>
+            </a:pPr>
+            <a:r>
+              <a:t>• Agricultural field delineation is NOT implemented. The brief asks to identify agricultural fields; this system segments water. ETCI-2021 has no parcel labels, so YOLO12's detection head is present but unsupervised, and the crop context comes from district statistics. This is the largest gap against the brief.</a:t>
+            </a:r>
+          </a:p>
+          <a:p>
+            <a:pPr>
+              <a:spcAft>
+                <a:spcPts val="900"/>
+              </a:spcAft>
+              <a:defRPr sz="1150">
+                <a:solidFill>
+                  <a:srgbClr val="0F233E"/>
+                </a:solidFill>
+              </a:defRPr>
+            </a:pPr>
+            <a:r>
+              <a:t>• Severity is derived from flood extent, not measured agronomic damage — ETCI-2021 has flood masks, not crop-damage ground truth. Validation against field-surveyed loss is NOT claimed.</a:t>
+            </a:r>
+          </a:p>
+          <a:p>
+            <a:pPr>
+              <a:spcAft>
+                <a:spcPts val="900"/>
+              </a:spcAft>
+              <a:defRPr sz="1150">
+                <a:solidFill>
+                  <a:srgbClr val="0F233E"/>
+                </a:solidFill>
+              </a:defRPr>
+            </a:pPr>
+            <a:r>
+              <a:t>• Only 20 Severe tiles exist in the whole pool (0.98%). Cross validation scores all 20 rather than the ~3 a single holdout would, but it remains the corpus ceiling.</a:t>
+            </a:r>
+          </a:p>
+          <a:p>
+            <a:pPr>
+              <a:spcAft>
+                <a:spcPts val="900"/>
+              </a:spcAft>
+              <a:defRPr sz="1150">
+                <a:solidFill>
+                  <a:srgbClr val="0F233E"/>
+                </a:solidFill>
+              </a:defRPr>
+            </a:pPr>
+            <a:r>
+              <a:t>• Tiers cap Healthy at 45% to make the benchmark usable; the natural 86.9% prior is reported alongside every result, not hidden.</a:t>
+            </a:r>
+          </a:p>
+          <a:p>
+            <a:pPr>
+              <a:spcAft>
+                <a:spcPts val="900"/>
+              </a:spcAft>
+              <a:defRPr sz="1150">
+                <a:solidFill>
+                  <a:srgbClr val="0F233E"/>
+                </a:solidFill>
+              </a:defRPr>
+            </a:pPr>
+            <a:r>
+              <a:t>• Training geography is the Ganges–Brahmaputra delta — a reasonable analogue for eastern India, but cross-region transfer is untested. FLNet states the same limitation about itself.</a:t>
+            </a:r>
+          </a:p>
+          <a:p>
+            <a:pPr>
+              <a:spcAft>
+                <a:spcPts val="900"/>
+              </a:spcAft>
+              <a:defRPr sz="1150">
+                <a:solidFill>
+                  <a:srgbClr val="0F233E"/>
+                </a:solidFill>
+              </a:defRPr>
+            </a:pPr>
+            <a:r>
+              <a:t>• Rupee figures use assumed per-severity loss coefficients, surfaced as parameters rather than fitted values.</a:t>
+            </a:r>
+          </a:p>
+        </p:txBody>
+      </p:sp>
+    </p:spTree>
+  </p:cSld>
+  <p:clrMapOvr>
+    <a:masterClrMapping/>
+  </p:clrMapOvr>
+</p:sld>
+</file>
+
+<file path=ppt/slides/slide16.xml><?xml version="1.0" encoding="utf-8"?>
+<p:sld xmlns:a="http://schemas.openxmlformats.org/drawingml/2006/main" xmlns:p="http://schemas.openxmlformats.org/presentationml/2006/main" xmlns:r="http://schemas.openxmlformats.org/officeDocument/2006/relationships">
+  <p:cSld>
+    <p:spTree>
+      <p:nvGrpSpPr>
+        <p:cNvPr id="1" name=""/>
+        <p:cNvGrpSpPr/>
+        <p:nvPr/>
+      </p:nvGrpSpPr>
+      <p:grpSpPr/>
+      <p:sp>
+        <p:nvSpPr>
+          <p:cNvPr id="2" name="TextBox 1"/>
+          <p:cNvSpPr txBox="1"/>
+          <p:nvPr/>
+        </p:nvSpPr>
+        <p:spPr>
+          <a:xfrm>
+            <a:off x="502920" y="310896"/>
+            <a:ext cx="11155680" cy="777240"/>
+          </a:xfrm>
+          <a:prstGeom prst="rect">
+            <a:avLst/>
+          </a:prstGeom>
+          <a:noFill/>
+        </p:spPr>
+        <p:txBody>
+          <a:bodyPr wrap="none">
+            <a:spAutoFit/>
+          </a:bodyPr>
+          <a:lstStyle/>
+          <a:p>
+            <a:pPr>
+              <a:defRPr sz="3000" b="1">
+                <a:solidFill>
+                  <a:srgbClr val="0F233E"/>
+                </a:solidFill>
+              </a:defRPr>
+            </a:pPr>
+            <a:r>
+              <a:t>What remains — the other 40%</a:t>
+            </a:r>
+          </a:p>
+        </p:txBody>
+      </p:sp>
+      <p:sp>
+        <p:nvSpPr>
+          <p:cNvPr id="3" name="TextBox 2"/>
+          <p:cNvSpPr txBox="1"/>
+          <p:nvPr/>
+        </p:nvSpPr>
+        <p:spPr>
+          <a:xfrm>
+            <a:off x="640080" y="1417320"/>
+            <a:ext cx="10972800" cy="4846320"/>
+          </a:xfrm>
+          <a:prstGeom prst="rect">
+            <a:avLst/>
+          </a:prstGeom>
+          <a:noFill/>
+        </p:spPr>
+        <p:txBody>
+          <a:bodyPr wrap="square">
+            <a:spAutoFit/>
+          </a:bodyPr>
+          <a:lstStyle/>
+          <a:p>
+            <a:pPr>
+              <a:spcAft>
+                <a:spcPts val="1300"/>
+              </a:spcAft>
+              <a:defRPr sz="1500">
+                <a:solidFill>
+                  <a:srgbClr val="0F233E"/>
+                </a:solidFill>
+              </a:defRPr>
+            </a:pPr>
+            <a:r>
+              <a:t>• Supervised agricultural field delineation — needs a cropland mask or parcel labels</a:t>
+            </a:r>
+          </a:p>
+          <a:p>
+            <a:pPr>
+              <a:spcAft>
+                <a:spcPts val="1300"/>
+              </a:spcAft>
+              <a:defRPr sz="1500">
+                <a:solidFill>
+                  <a:srgbClr val="0F233E"/>
+                </a:solidFill>
+              </a:defRPr>
+            </a:pPr>
+            <a:r>
+              <a:t>• Validation against field-surveyed crop loss (BFCD-22, or state revenue records)</a:t>
+            </a:r>
+          </a:p>
+          <a:p>
+            <a:pPr>
+              <a:spcAft>
+                <a:spcPts val="1300"/>
+              </a:spcAft>
+              <a:defRPr sz="1500">
+                <a:solidFill>
+                  <a:srgbClr val="0F233E"/>
+                </a:solidFill>
+              </a:defRPr>
+            </a:pPr>
+            <a:r>
+              <a:t>• Cross-region transfer to Indian districts, and domain adaptation</a:t>
+            </a:r>
+          </a:p>
+          <a:p>
+            <a:pPr>
+              <a:spcAft>
+                <a:spcPts val="1300"/>
+              </a:spcAft>
+              <a:defRPr sz="1500">
+                <a:solidFill>
+                  <a:srgbClr val="0F233E"/>
+                </a:solidFill>
+              </a:defRPr>
+            </a:pPr>
+            <a:r>
+              <a:t>• Sentinel-1 + Sentinel-2 fusion, as FLNet's future work proposes</a:t>
+            </a:r>
+          </a:p>
+          <a:p>
+            <a:pPr>
+              <a:spcAft>
+                <a:spcPts val="1300"/>
+              </a:spcAft>
+              <a:defRPr sz="1500">
+                <a:solidFill>
+                  <a:srgbClr val="0F233E"/>
+                </a:solidFill>
+              </a:defRPr>
+            </a:pPr>
+            <a:r>
+              <a:t>• Calibration and uncertainty estimates, as the Explainable SAR paper proposes</a:t>
+            </a:r>
+          </a:p>
+          <a:p>
+            <a:pPr>
+              <a:spcAft>
+                <a:spcPts val="1300"/>
+              </a:spcAft>
+              <a:defRPr sz="1500">
+                <a:solidFill>
+                  <a:srgbClr val="0F233E"/>
+                </a:solidFill>
+              </a:defRPr>
+            </a:pPr>
+            <a:r>
+              <a:t>• 10-fold cross validation extended to the image pipeline once compute allows</a:t>
+            </a:r>
+          </a:p>
+          <a:p>
+            <a:pPr>
+              <a:spcAft>
+                <a:spcPts val="1300"/>
+              </a:spcAft>
+              <a:defRPr sz="1500">
+                <a:solidFill>
+                  <a:srgbClr val="0F233E"/>
+                </a:solidFill>
+              </a:defRPr>
+            </a:pPr>
+            <a:r>
+              <a:t>• Higher tiers (T4) and longer schedules on stronger hardware</a:t>
+            </a:r>
+          </a:p>
+        </p:txBody>
+      </p:sp>
+    </p:spTree>
+  </p:cSld>
+  <p:clrMapOvr>
+    <a:masterClrMapping/>
+  </p:clrMapOvr>
+</p:sld>
+</file>
+
+<file path=ppt/slides/slide17.xml><?xml version="1.0" encoding="utf-8"?>
 <p:sld xmlns:a="http://schemas.openxmlformats.org/drawingml/2006/main" xmlns:p="http://schemas.openxmlformats.org/presentationml/2006/main" xmlns:r="http://schemas.openxmlformats.org/officeDocument/2006/relationships">
   <p:cSld>
     <p:spTree>
@@ -5865,7 +7743,7 @@
               </a:defRPr>
             </a:pPr>
             <a:r>
-              <a:t>The five hybrid architectures</a:t>
+              <a:t>Two hybrid architectures, developed in depth</a:t>
             </a:r>
           </a:p>
           <a:p>
@@ -5877,7 +7755,7 @@
               </a:defRPr>
             </a:pPr>
             <a:r>
-              <a:t>Shared U-Net decoder and shared severity head — so the comparison isolates the encoder</a:t>
+              <a:t>All five were implemented and benchmarked; two were carried forward. Shared decoder and head.</a:t>
             </a:r>
           </a:p>
         </p:txBody>
@@ -5892,7 +7770,7 @@
         </p:nvGraphicFramePr>
         <p:xfrm>
           <a:off x="457200" y="1371600"/>
-          <a:ext cx="11292840" cy="3931920"/>
+          <a:ext cx="11292840" cy="1920240"/>
         </p:xfrm>
         <a:graphic>
           <a:graphicData uri="http://schemas.openxmlformats.org/drawingml/2006/table">
@@ -5901,12 +7779,13 @@
                 <a:tableStyleId>{5C22544A-7EE6-4342-B048-85BDC9FD1C3A}</a:tableStyleId>
               </a:tblPr>
               <a:tblGrid>
-                <a:gridCol w="411480"/>
+                <a:gridCol w="2011680"/>
+                <a:gridCol w="731520"/>
                 <a:gridCol w="2560320"/>
-                <a:gridCol w="2834640"/>
-                <a:gridCol w="5486400"/>
+                <a:gridCol w="3017520"/>
+                <a:gridCol w="2971800"/>
               </a:tblGrid>
-              <a:tr h="655320">
+              <a:tr h="640080">
                 <a:tc>
                   <a:txBody>
                     <a:bodyPr/>
@@ -5920,7 +7799,7 @@
                         </a:defRPr>
                       </a:pPr>
                       <a:r>
-                        <a:t>#</a:t>
+                        <a:t>Hybrid</a:t>
                       </a:r>
                     </a:p>
                   </a:txBody>
@@ -5943,7 +7822,7 @@
                         </a:defRPr>
                       </a:pPr>
                       <a:r>
-                        <a:t>Hybrid</a:t>
+                        <a:t>Params</a:t>
                       </a:r>
                     </a:p>
                   </a:txBody>
@@ -5989,7 +7868,7 @@
                         </a:defRPr>
                       </a:pPr>
                       <a:r>
-                        <a:t>Why it is in the benchmark</a:t>
+                        <a:t>Input</a:t>
                       </a:r>
                     </a:p>
                   </a:txBody>
@@ -5999,8 +7878,31 @@
                     </a:solidFill>
                   </a:tcPr>
                 </a:tc>
+                <a:tc>
+                  <a:txBody>
+                    <a:bodyPr/>
+                    <a:lstStyle/>
+                    <a:p>
+                      <a:pPr>
+                        <a:defRPr sz="1000" b="1">
+                          <a:solidFill>
+                            <a:srgbClr val="FFFFFF"/>
+                          </a:solidFill>
+                        </a:defRPr>
+                      </a:pPr>
+                      <a:r>
+                        <a:t>Why this one</a:t>
+                      </a:r>
+                    </a:p>
+                  </a:txBody>
+                  <a:tcPr>
+                    <a:solidFill>
+                      <a:srgbClr val="0F233E"/>
+                    </a:solidFill>
+                  </a:tcPr>
+                </a:tc>
               </a:tr>
-              <a:tr h="655320">
+              <a:tr h="640080">
                 <a:tc>
                   <a:txBody>
                     <a:bodyPr/>
@@ -6014,7 +7916,7 @@
                         </a:defRPr>
                       </a:pPr>
                       <a:r>
-                        <a:t>1</a:t>
+                        <a:t>YOLO12 + U-Net</a:t>
                       </a:r>
                     </a:p>
                   </a:txBody>
@@ -6033,7 +7935,7 @@
                         </a:defRPr>
                       </a:pPr>
                       <a:r>
-                        <a:t>YOLO12 + U-Net</a:t>
+                        <a:t>5.5M</a:t>
                       </a:r>
                     </a:p>
                   </a:txBody>
@@ -6076,14 +7978,43 @@
                         </a:defRPr>
                       </a:pPr>
                       <a:r>
-                        <a:t>Detects field parcels while segmenting water inside them</a:t>
+                        <a:t>6-channel change stack</a:t>
+                      </a:r>
+                    </a:p>
+                    <a:p>
+                      <a:r>
+                        <a:t>[post VV,VH,ratio, ΔVV,ΔVH,Δratio]</a:t>
+                      </a:r>
+                    </a:p>
+                  </a:txBody>
+                  <a:tcPr/>
+                </a:tc>
+                <a:tc>
+                  <a:txBody>
+                    <a:bodyPr/>
+                    <a:lstStyle/>
+                    <a:p>
+                      <a:pPr>
+                        <a:defRPr sz="1000">
+                          <a:solidFill>
+                            <a:srgbClr val="0F233E"/>
+                          </a:solidFill>
+                        </a:defRPr>
+                      </a:pPr>
+                      <a:r>
+                        <a:t>Was the weakest, for a diagnosable</a:t>
+                      </a:r>
+                    </a:p>
+                    <a:p>
+                      <a:r>
+                        <a:t>reason: from scratch, peaked at epoch 1</a:t>
                       </a:r>
                     </a:p>
                   </a:txBody>
                   <a:tcPr/>
                 </a:tc>
               </a:tr>
-              <a:tr h="655320">
+              <a:tr h="640080">
                 <a:tc>
                   <a:txBody>
                     <a:bodyPr/>
@@ -6097,7 +8028,7 @@
                         </a:defRPr>
                       </a:pPr>
                       <a:r>
-                        <a:t>2</a:t>
+                        <a:t>CNN + LSTM</a:t>
                       </a:r>
                     </a:p>
                   </a:txBody>
@@ -6116,7 +8047,7 @@
                         </a:defRPr>
                       </a:pPr>
                       <a:r>
-                        <a:t>ResNet + U-Net</a:t>
+                        <a:t>9.0M</a:t>
                       </a:r>
                     </a:p>
                   </a:txBody>
@@ -6135,7 +8066,12 @@
                         </a:defRPr>
                       </a:pPr>
                       <a:r>
-                        <a:t>timm resnet34</a:t>
+                        <a:t>Shared CNN +</a:t>
+                      </a:r>
+                    </a:p>
+                    <a:p>
+                      <a:r>
+                        <a:t>ConvLSTM at every scale</a:t>
                       </a:r>
                     </a:p>
                   </a:txBody>
@@ -6154,14 +8090,17 @@
                         </a:defRPr>
                       </a:pPr>
                       <a:r>
-                        <a:t>The established baseline to measure against</a:t>
-                      </a:r>
-                    </a:p>
-                  </a:txBody>
-                  <a:tcPr/>
-                </a:tc>
-              </a:tr>
-              <a:tr h="655320">
+                        <a:t>Ordered pre/post pair</a:t>
+                      </a:r>
+                    </a:p>
+                    <a:p>
+                      <a:r>
+                        <a:t>[T=2, 3 channels]</a:t>
+                      </a:r>
+                    </a:p>
+                  </a:txBody>
+                  <a:tcPr/>
+                </a:tc>
                 <a:tc>
                   <a:txBody>
                     <a:bodyPr/>
@@ -6175,225 +8114,12 @@
                         </a:defRPr>
                       </a:pPr>
                       <a:r>
-                        <a:t>3</a:t>
-                      </a:r>
-                    </a:p>
-                  </a:txBody>
-                  <a:tcPr/>
-                </a:tc>
-                <a:tc>
-                  <a:txBody>
-                    <a:bodyPr/>
-                    <a:lstStyle/>
-                    <a:p>
-                      <a:pPr>
-                        <a:defRPr sz="1000">
-                          <a:solidFill>
-                            <a:srgbClr val="0F233E"/>
-                          </a:solidFill>
-                        </a:defRPr>
-                      </a:pPr>
-                      <a:r>
-                        <a:t>EfficientNet + Attention</a:t>
-                      </a:r>
-                    </a:p>
-                  </a:txBody>
-                  <a:tcPr/>
-                </a:tc>
-                <a:tc>
-                  <a:txBody>
-                    <a:bodyPr/>
-                    <a:lstStyle/>
-                    <a:p>
-                      <a:pPr>
-                        <a:defRPr sz="1000">
-                          <a:solidFill>
-                            <a:srgbClr val="0F233E"/>
-                          </a:solidFill>
-                        </a:defRPr>
-                      </a:pPr>
-                      <a:r>
-                        <a:t>efficientnet_b0 + CBAM</a:t>
-                      </a:r>
-                    </a:p>
-                    <a:p>
-                      <a:r>
-                        <a:t>+ attention-gated skips</a:t>
-                      </a:r>
-                    </a:p>
-                  </a:txBody>
-                  <a:tcPr/>
-                </a:tc>
-                <a:tc>
-                  <a:txBody>
-                    <a:bodyPr/>
-                    <a:lstStyle/>
-                    <a:p>
-                      <a:pPr>
-                        <a:defRPr sz="1000">
-                          <a:solidFill>
-                            <a:srgbClr val="0F233E"/>
-                          </a:solidFill>
-                        </a:defRPr>
-                      </a:pPr>
-                      <a:r>
-                        <a:t>Best accuracy per FLOP; the shape TDAVM-UNet validates for agriculture</a:t>
-                      </a:r>
-                    </a:p>
-                  </a:txBody>
-                  <a:tcPr/>
-                </a:tc>
-              </a:tr>
-              <a:tr h="655320">
-                <a:tc>
-                  <a:txBody>
-                    <a:bodyPr/>
-                    <a:lstStyle/>
-                    <a:p>
-                      <a:pPr>
-                        <a:defRPr sz="1000">
-                          <a:solidFill>
-                            <a:srgbClr val="0F233E"/>
-                          </a:solidFill>
-                        </a:defRPr>
-                      </a:pPr>
-                      <a:r>
-                        <a:t>4</a:t>
-                      </a:r>
-                    </a:p>
-                  </a:txBody>
-                  <a:tcPr/>
-                </a:tc>
-                <a:tc>
-                  <a:txBody>
-                    <a:bodyPr/>
-                    <a:lstStyle/>
-                    <a:p>
-                      <a:pPr>
-                        <a:defRPr sz="1000">
-                          <a:solidFill>
-                            <a:srgbClr val="0F233E"/>
-                          </a:solidFill>
-                        </a:defRPr>
-                      </a:pPr>
-                      <a:r>
-                        <a:t>Swin Transformer + U-Net</a:t>
-                      </a:r>
-                    </a:p>
-                  </a:txBody>
-                  <a:tcPr/>
-                </a:tc>
-                <a:tc>
-                  <a:txBody>
-                    <a:bodyPr/>
-                    <a:lstStyle/>
-                    <a:p>
-                      <a:pPr>
-                        <a:defRPr sz="1000">
-                          <a:solidFill>
-                            <a:srgbClr val="0F233E"/>
-                          </a:solidFill>
-                        </a:defRPr>
-                      </a:pPr>
-                      <a:r>
-                        <a:t>swinv2_tiny</a:t>
-                      </a:r>
-                    </a:p>
-                  </a:txBody>
-                  <a:tcPr/>
-                </a:tc>
-                <a:tc>
-                  <a:txBody>
-                    <a:bodyPr/>
-                    <a:lstStyle/>
-                    <a:p>
-                      <a:pPr>
-                        <a:defRPr sz="1000">
-                          <a:solidFill>
-                            <a:srgbClr val="0F233E"/>
-                          </a:solidFill>
-                        </a:defRPr>
-                      </a:pPr>
-                      <a:r>
-                        <a:t>Global receptive field at linear cost — long-range boundary precision</a:t>
-                      </a:r>
-                    </a:p>
-                  </a:txBody>
-                  <a:tcPr/>
-                </a:tc>
-              </a:tr>
-              <a:tr h="655320">
-                <a:tc>
-                  <a:txBody>
-                    <a:bodyPr/>
-                    <a:lstStyle/>
-                    <a:p>
-                      <a:pPr>
-                        <a:defRPr sz="1000">
-                          <a:solidFill>
-                            <a:srgbClr val="0F233E"/>
-                          </a:solidFill>
-                        </a:defRPr>
-                      </a:pPr>
-                      <a:r>
-                        <a:t>5</a:t>
-                      </a:r>
-                    </a:p>
-                  </a:txBody>
-                  <a:tcPr/>
-                </a:tc>
-                <a:tc>
-                  <a:txBody>
-                    <a:bodyPr/>
-                    <a:lstStyle/>
-                    <a:p>
-                      <a:pPr>
-                        <a:defRPr sz="1000">
-                          <a:solidFill>
-                            <a:srgbClr val="0F233E"/>
-                          </a:solidFill>
-                        </a:defRPr>
-                      </a:pPr>
-                      <a:r>
-                        <a:t>CNN + LSTM</a:t>
-                      </a:r>
-                    </a:p>
-                  </a:txBody>
-                  <a:tcPr/>
-                </a:tc>
-                <a:tc>
-                  <a:txBody>
-                    <a:bodyPr/>
-                    <a:lstStyle/>
-                    <a:p>
-                      <a:pPr>
-                        <a:defRPr sz="1000">
-                          <a:solidFill>
-                            <a:srgbClr val="0F233E"/>
-                          </a:solidFill>
-                        </a:defRPr>
-                      </a:pPr>
-                      <a:r>
-                        <a:t>CNN + ConvLSTM at every scale</a:t>
-                      </a:r>
-                    </a:p>
-                  </a:txBody>
-                  <a:tcPr/>
-                </a:tc>
-                <a:tc>
-                  <a:txBody>
-                    <a:bodyPr/>
-                    <a:lstStyle/>
-                    <a:p>
-                      <a:pPr>
-                        <a:defRPr sz="1000">
-                          <a:solidFill>
-                            <a:srgbClr val="0F233E"/>
-                          </a:solidFill>
-                        </a:defRPr>
-                      </a:pPr>
-                      <a:r>
-                        <a:t>Consumes the real pre-monsoon / monsoon pair</a:t>
+                        <a:t>The only model of the five that</a:t>
+                      </a:r>
+                    </a:p>
+                    <a:p>
+                      <a:r>
+                        <a:t>did not overfit (gap +0.093)</a:t>
                       </a:r>
                     </a:p>
                   </a:txBody>
@@ -6412,8 +8138,8 @@
         </p:nvSpPr>
         <p:spPr>
           <a:xfrm>
-            <a:off x="457200" y="5486400"/>
-            <a:ext cx="11292840" cy="1005840"/>
+            <a:off x="640080" y="3520440"/>
+            <a:ext cx="10972800" cy="4846320"/>
           </a:xfrm>
           <a:prstGeom prst="rect">
             <a:avLst/>
@@ -6427,14 +8153,32 @@
           <a:lstStyle/>
           <a:p>
             <a:pPr>
-              <a:defRPr sz="1100">
-                <a:solidFill>
-                  <a:srgbClr val="475569"/>
-                </a:solidFill>
-              </a:defRPr>
-            </a:pPr>
-            <a:r>
-              <a:t>Shared head: the severity classifier reads average-pooled features, max-pooled features, and mean(sigmoid(segmentation)) — the predicted net flood fraction. Since the severity label is defined as that fraction, the classifier is handed the exact quantity the target is built from.</a:t>
+              <a:spcAft>
+                <a:spcPts val="1200"/>
+              </a:spcAft>
+              <a:defRPr sz="1250">
+                <a:solidFill>
+                  <a:srgbClr val="0F233E"/>
+                </a:solidFill>
+              </a:defRPr>
+            </a:pPr>
+            <a:r>
+              <a:t>• They are architecturally complementary: one reaches the pre→post change through an explicit difference channel, the other through recurrence. Comparing those says something; comparing two ImageNet CNNs would not.</a:t>
+            </a:r>
+          </a:p>
+          <a:p>
+            <a:pPr>
+              <a:spcAft>
+                <a:spcPts val="1200"/>
+              </a:spcAft>
+              <a:defRPr sz="1250">
+                <a:solidFill>
+                  <a:srgbClr val="0F233E"/>
+                </a:solidFill>
+              </a:defRPr>
+            </a:pPr>
+            <a:r>
+              <a:t>• The other three (ResNet+U-Net, EfficientNet+Attention, Swin+U-Net) remain in the repo with their benchmarked results archived — this is depth over breadth, stated up front.</a:t>
             </a:r>
           </a:p>
         </p:txBody>
@@ -6487,7 +8231,7 @@
               </a:defRPr>
             </a:pPr>
             <a:r>
-              <a:t>Data</a:t>
+              <a:t>The problem was memorisation, not architecture</a:t>
             </a:r>
           </a:p>
           <a:p>
@@ -6499,21 +8243,414 @@
               </a:defRPr>
             </a:pPr>
             <a:r>
-              <a:t>Both sources public, no credentials, nothing bulk-downloaded</a:t>
-            </a:r>
-          </a:p>
-        </p:txBody>
-      </p:sp>
-      <p:sp>
-        <p:nvSpPr>
-          <p:cNvPr id="3" name="TextBox 2"/>
+              <a:t>Train-val macro-F1 gap in the five-model benchmark</a:t>
+            </a:r>
+          </a:p>
+        </p:txBody>
+      </p:sp>
+      <p:graphicFrame>
+        <p:nvGraphicFramePr>
+          <p:cNvPr id="3" name="Table 2"/>
+          <p:cNvGraphicFramePr>
+            <a:graphicFrameLocks noGrp="1"/>
+          </p:cNvGraphicFramePr>
+          <p:nvPr/>
+        </p:nvGraphicFramePr>
+        <p:xfrm>
+          <a:off x="548640" y="1371600"/>
+          <a:ext cx="5394960" cy="2377440"/>
+        </p:xfrm>
+        <a:graphic>
+          <a:graphicData uri="http://schemas.openxmlformats.org/drawingml/2006/table">
+            <a:tbl>
+              <a:tblPr firstRow="1" bandRow="1">
+                <a:tableStyleId>{5C22544A-7EE6-4342-B048-85BDC9FD1C3A}</a:tableStyleId>
+              </a:tblPr>
+              <a:tblGrid>
+                <a:gridCol w="1798320"/>
+                <a:gridCol w="1798320"/>
+                <a:gridCol w="1798320"/>
+              </a:tblGrid>
+              <a:tr h="396240">
+                <a:tc>
+                  <a:txBody>
+                    <a:bodyPr/>
+                    <a:lstStyle/>
+                    <a:p>
+                      <a:pPr>
+                        <a:defRPr sz="1100" b="1">
+                          <a:solidFill>
+                            <a:srgbClr val="FFFFFF"/>
+                          </a:solidFill>
+                        </a:defRPr>
+                      </a:pPr>
+                      <a:r>
+                        <a:t>Model</a:t>
+                      </a:r>
+                    </a:p>
+                  </a:txBody>
+                  <a:tcPr>
+                    <a:solidFill>
+                      <a:srgbClr val="0F233E"/>
+                    </a:solidFill>
+                  </a:tcPr>
+                </a:tc>
+                <a:tc>
+                  <a:txBody>
+                    <a:bodyPr/>
+                    <a:lstStyle/>
+                    <a:p>
+                      <a:pPr>
+                        <a:defRPr sz="1100" b="1">
+                          <a:solidFill>
+                            <a:srgbClr val="FFFFFF"/>
+                          </a:solidFill>
+                        </a:defRPr>
+                      </a:pPr>
+                      <a:r>
+                        <a:t>Gap</a:t>
+                      </a:r>
+                    </a:p>
+                  </a:txBody>
+                  <a:tcPr>
+                    <a:solidFill>
+                      <a:srgbClr val="0F233E"/>
+                    </a:solidFill>
+                  </a:tcPr>
+                </a:tc>
+                <a:tc>
+                  <a:txBody>
+                    <a:bodyPr/>
+                    <a:lstStyle/>
+                    <a:p>
+                      <a:pPr>
+                        <a:defRPr sz="1100" b="1">
+                          <a:solidFill>
+                            <a:srgbClr val="FFFFFF"/>
+                          </a:solidFill>
+                        </a:defRPr>
+                      </a:pPr>
+                      <a:r>
+                        <a:t>Verdict</a:t>
+                      </a:r>
+                    </a:p>
+                  </a:txBody>
+                  <a:tcPr>
+                    <a:solidFill>
+                      <a:srgbClr val="0F233E"/>
+                    </a:solidFill>
+                  </a:tcPr>
+                </a:tc>
+              </a:tr>
+              <a:tr h="396240">
+                <a:tc>
+                  <a:txBody>
+                    <a:bodyPr/>
+                    <a:lstStyle/>
+                    <a:p>
+                      <a:pPr>
+                        <a:defRPr sz="1100">
+                          <a:solidFill>
+                            <a:srgbClr val="0F233E"/>
+                          </a:solidFill>
+                        </a:defRPr>
+                      </a:pPr>
+                      <a:r>
+                        <a:t>Swin + U-Net</a:t>
+                      </a:r>
+                    </a:p>
+                  </a:txBody>
+                  <a:tcPr/>
+                </a:tc>
+                <a:tc>
+                  <a:txBody>
+                    <a:bodyPr/>
+                    <a:lstStyle/>
+                    <a:p>
+                      <a:pPr>
+                        <a:defRPr sz="1100">
+                          <a:solidFill>
+                            <a:srgbClr val="0F233E"/>
+                          </a:solidFill>
+                        </a:defRPr>
+                      </a:pPr>
+                      <a:r>
+                        <a:t>+0.350</a:t>
+                      </a:r>
+                    </a:p>
+                  </a:txBody>
+                  <a:tcPr/>
+                </a:tc>
+                <a:tc>
+                  <a:txBody>
+                    <a:bodyPr/>
+                    <a:lstStyle/>
+                    <a:p>
+                      <a:pPr>
+                        <a:defRPr sz="1100">
+                          <a:solidFill>
+                            <a:srgbClr val="0F233E"/>
+                          </a:solidFill>
+                        </a:defRPr>
+                      </a:pPr>
+                      <a:r>
+                        <a:t>memorising</a:t>
+                      </a:r>
+                    </a:p>
+                  </a:txBody>
+                  <a:tcPr/>
+                </a:tc>
+              </a:tr>
+              <a:tr h="396240">
+                <a:tc>
+                  <a:txBody>
+                    <a:bodyPr/>
+                    <a:lstStyle/>
+                    <a:p>
+                      <a:pPr>
+                        <a:defRPr sz="1100">
+                          <a:solidFill>
+                            <a:srgbClr val="0F233E"/>
+                          </a:solidFill>
+                        </a:defRPr>
+                      </a:pPr>
+                      <a:r>
+                        <a:t>EfficientNet + Attention</a:t>
+                      </a:r>
+                    </a:p>
+                  </a:txBody>
+                  <a:tcPr/>
+                </a:tc>
+                <a:tc>
+                  <a:txBody>
+                    <a:bodyPr/>
+                    <a:lstStyle/>
+                    <a:p>
+                      <a:pPr>
+                        <a:defRPr sz="1100">
+                          <a:solidFill>
+                            <a:srgbClr val="0F233E"/>
+                          </a:solidFill>
+                        </a:defRPr>
+                      </a:pPr>
+                      <a:r>
+                        <a:t>+0.319</a:t>
+                      </a:r>
+                    </a:p>
+                  </a:txBody>
+                  <a:tcPr/>
+                </a:tc>
+                <a:tc>
+                  <a:txBody>
+                    <a:bodyPr/>
+                    <a:lstStyle/>
+                    <a:p>
+                      <a:pPr>
+                        <a:defRPr sz="1100">
+                          <a:solidFill>
+                            <a:srgbClr val="0F233E"/>
+                          </a:solidFill>
+                        </a:defRPr>
+                      </a:pPr>
+                      <a:r>
+                        <a:t>memorising</a:t>
+                      </a:r>
+                    </a:p>
+                  </a:txBody>
+                  <a:tcPr/>
+                </a:tc>
+              </a:tr>
+              <a:tr h="396240">
+                <a:tc>
+                  <a:txBody>
+                    <a:bodyPr/>
+                    <a:lstStyle/>
+                    <a:p>
+                      <a:pPr>
+                        <a:defRPr sz="1100">
+                          <a:solidFill>
+                            <a:srgbClr val="0F233E"/>
+                          </a:solidFill>
+                        </a:defRPr>
+                      </a:pPr>
+                      <a:r>
+                        <a:t>ResNet + U-Net</a:t>
+                      </a:r>
+                    </a:p>
+                  </a:txBody>
+                  <a:tcPr/>
+                </a:tc>
+                <a:tc>
+                  <a:txBody>
+                    <a:bodyPr/>
+                    <a:lstStyle/>
+                    <a:p>
+                      <a:pPr>
+                        <a:defRPr sz="1100">
+                          <a:solidFill>
+                            <a:srgbClr val="0F233E"/>
+                          </a:solidFill>
+                        </a:defRPr>
+                      </a:pPr>
+                      <a:r>
+                        <a:t>+0.292</a:t>
+                      </a:r>
+                    </a:p>
+                  </a:txBody>
+                  <a:tcPr/>
+                </a:tc>
+                <a:tc>
+                  <a:txBody>
+                    <a:bodyPr/>
+                    <a:lstStyle/>
+                    <a:p>
+                      <a:pPr>
+                        <a:defRPr sz="1100">
+                          <a:solidFill>
+                            <a:srgbClr val="0F233E"/>
+                          </a:solidFill>
+                        </a:defRPr>
+                      </a:pPr>
+                      <a:r>
+                        <a:t>memorising</a:t>
+                      </a:r>
+                    </a:p>
+                  </a:txBody>
+                  <a:tcPr/>
+                </a:tc>
+              </a:tr>
+              <a:tr h="396240">
+                <a:tc>
+                  <a:txBody>
+                    <a:bodyPr/>
+                    <a:lstStyle/>
+                    <a:p>
+                      <a:pPr>
+                        <a:defRPr sz="1100">
+                          <a:solidFill>
+                            <a:srgbClr val="0F233E"/>
+                          </a:solidFill>
+                        </a:defRPr>
+                      </a:pPr>
+                      <a:r>
+                        <a:t>YOLO12 + U-Net</a:t>
+                      </a:r>
+                    </a:p>
+                  </a:txBody>
+                  <a:tcPr/>
+                </a:tc>
+                <a:tc>
+                  <a:txBody>
+                    <a:bodyPr/>
+                    <a:lstStyle/>
+                    <a:p>
+                      <a:pPr>
+                        <a:defRPr sz="1100">
+                          <a:solidFill>
+                            <a:srgbClr val="0F233E"/>
+                          </a:solidFill>
+                        </a:defRPr>
+                      </a:pPr>
+                      <a:r>
+                        <a:t>+0.185</a:t>
+                      </a:r>
+                    </a:p>
+                  </a:txBody>
+                  <a:tcPr/>
+                </a:tc>
+                <a:tc>
+                  <a:txBody>
+                    <a:bodyPr/>
+                    <a:lstStyle/>
+                    <a:p>
+                      <a:pPr>
+                        <a:defRPr sz="1100">
+                          <a:solidFill>
+                            <a:srgbClr val="0F233E"/>
+                          </a:solidFill>
+                        </a:defRPr>
+                      </a:pPr>
+                      <a:r>
+                        <a:t>memorising — peaked at epoch 1</a:t>
+                      </a:r>
+                    </a:p>
+                  </a:txBody>
+                  <a:tcPr/>
+                </a:tc>
+              </a:tr>
+              <a:tr h="396240">
+                <a:tc>
+                  <a:txBody>
+                    <a:bodyPr/>
+                    <a:lstStyle/>
+                    <a:p>
+                      <a:pPr>
+                        <a:defRPr sz="1100">
+                          <a:solidFill>
+                            <a:srgbClr val="0F233E"/>
+                          </a:solidFill>
+                        </a:defRPr>
+                      </a:pPr>
+                      <a:r>
+                        <a:t>CNN + LSTM</a:t>
+                      </a:r>
+                    </a:p>
+                  </a:txBody>
+                  <a:tcPr/>
+                </a:tc>
+                <a:tc>
+                  <a:txBody>
+                    <a:bodyPr/>
+                    <a:lstStyle/>
+                    <a:p>
+                      <a:pPr>
+                        <a:defRPr sz="1100">
+                          <a:solidFill>
+                            <a:srgbClr val="0F233E"/>
+                          </a:solidFill>
+                        </a:defRPr>
+                      </a:pPr>
+                      <a:r>
+                        <a:t>+0.093</a:t>
+                      </a:r>
+                    </a:p>
+                  </a:txBody>
+                  <a:tcPr/>
+                </a:tc>
+                <a:tc>
+                  <a:txBody>
+                    <a:bodyPr/>
+                    <a:lstStyle/>
+                    <a:p>
+                      <a:pPr>
+                        <a:defRPr sz="1100">
+                          <a:solidFill>
+                            <a:srgbClr val="0F233E"/>
+                          </a:solidFill>
+                        </a:defRPr>
+                      </a:pPr>
+                      <a:r>
+                        <a:t>the only healthy model</a:t>
+                      </a:r>
+                    </a:p>
+                  </a:txBody>
+                  <a:tcPr/>
+                </a:tc>
+              </a:tr>
+            </a:tbl>
+          </a:graphicData>
+        </a:graphic>
+      </p:graphicFrame>
+      <p:sp>
+        <p:nvSpPr>
+          <p:cNvPr id="4" name="TextBox 3"/>
           <p:cNvSpPr txBox="1"/>
           <p:nvPr/>
         </p:nvSpPr>
         <p:spPr>
           <a:xfrm>
-            <a:off x="640080" y="1417320"/>
-            <a:ext cx="10972800" cy="4846320"/>
+            <a:off x="6309360" y="1417320"/>
+            <a:ext cx="5486400" cy="4846320"/>
           </a:xfrm>
           <a:prstGeom prst="rect">
             <a:avLst/>
@@ -6528,136 +8665,156 @@
           <a:p>
             <a:pPr>
               <a:spcAft>
-                <a:spcPts val="800"/>
-              </a:spcAft>
-              <a:defRPr sz="1400">
-                <a:solidFill>
-                  <a:srgbClr val="0F233E"/>
-                </a:solidFill>
-              </a:defRPr>
-            </a:pPr>
-            <a:r>
-              <a:t>• Imagery — ETCI-2021 Sentinel-1 SAR over Bangladesh (Ganges–Brahmaputra delta)</a:t>
-            </a:r>
-          </a:p>
-          <a:p>
-            <a:pPr lvl="1">
-              <a:spcAft>
-                <a:spcPts val="800"/>
+                <a:spcPts val="700"/>
               </a:spcAft>
               <a:defRPr sz="1200">
                 <a:solidFill>
-                  <a:srgbClr val="475569"/>
-                </a:solidFill>
-              </a:defRPr>
-            </a:pPr>
-            <a:r>
-              <a:t>– 2,032 tiles with a genuine pre/post pair: 2017-03-14 pre-monsoon and 2017-06-06 monsoon flood</a:t>
-            </a:r>
-          </a:p>
-          <a:p>
-            <a:pPr lvl="1">
+                  <a:srgbClr val="0F233E"/>
+                </a:solidFill>
+              </a:defRPr>
+            </a:pPr>
+            <a:r>
+              <a:t>• 5-fold cross validation — every tile scored out-of-fold</a:t>
+            </a:r>
+          </a:p>
+          <a:p>
+            <a:pPr>
               <a:spcAft>
-                <a:spcPts val="800"/>
+                <a:spcPts val="700"/>
               </a:spcAft>
               <a:defRPr sz="1200">
                 <a:solidFill>
-                  <a:srgbClr val="475569"/>
-                </a:solidFill>
-              </a:defRPr>
-            </a:pPr>
-            <a:r>
-              <a:t>– Each carries VV, VH, a flood mask and a permanent-water mask at both dates</a:t>
+                  <a:srgbClr val="0F233E"/>
+                </a:solidFill>
+              </a:defRPr>
+            </a:pPr>
+            <a:r>
+              <a:t>• Change-detection input (the static scene cancels)</a:t>
             </a:r>
           </a:p>
           <a:p>
             <a:pPr>
               <a:spcAft>
-                <a:spcPts val="800"/>
-              </a:spcAft>
-              <a:defRPr sz="1400">
-                <a:solidFill>
-                  <a:srgbClr val="0F233E"/>
-                </a:solidFill>
-              </a:defRPr>
-            </a:pPr>
-            <a:r>
-              <a:t>• Agriculture — ICRISAT district statistics: 310 Indian districts · 23 crops · 2010–2017</a:t>
-            </a:r>
-          </a:p>
-          <a:p>
-            <a:pPr lvl="1">
-              <a:spcAft>
-                <a:spcPts val="800"/>
+                <a:spcPts val="700"/>
               </a:spcAft>
               <a:defRPr sz="1200">
                 <a:solidFill>
-                  <a:srgbClr val="475569"/>
-                </a:solidFill>
-              </a:defRPr>
-            </a:pPr>
-            <a:r>
-              <a:t>– Label from per-district yield anomaly → a real 10.9 : 1 class imbalance, which is what justifies SMOTE</a:t>
+                  <a:srgbClr val="0F233E"/>
+                </a:solidFill>
+              </a:defRPr>
+            </a:pPr>
+            <a:r>
+              <a:t>• YOLO12 narrowed 9.8M → 5.5M</a:t>
             </a:r>
           </a:p>
           <a:p>
             <a:pPr>
               <a:spcAft>
-                <a:spcPts val="800"/>
-              </a:spcAft>
-              <a:defRPr sz="1400">
-                <a:solidFill>
-                  <a:srgbClr val="0F233E"/>
-                </a:solidFill>
-              </a:defRPr>
-            </a:pPr>
-            <a:r>
-              <a:t>• </a:t>
-            </a:r>
-          </a:p>
-          <a:p>
-            <a:pPr>
-              <a:spcAft>
-                <a:spcPts val="800"/>
-              </a:spcAft>
-              <a:defRPr sz="1400">
-                <a:solidFill>
-                  <a:srgbClr val="0F233E"/>
-                </a:solidFill>
-              </a:defRPr>
-            </a:pPr>
-            <a:r>
-              <a:t>• Severity = net flood fraction (flood − permanent water), binned at 2% / 10% / 33%</a:t>
-            </a:r>
-          </a:p>
-          <a:p>
-            <a:pPr lvl="1">
-              <a:spcAft>
-                <a:spcPts val="800"/>
+                <a:spcPts val="700"/>
               </a:spcAft>
               <a:defRPr sz="1200">
                 <a:solidFill>
-                  <a:srgbClr val="475569"/>
-                </a:solidFill>
-              </a:defRPr>
-            </a:pPr>
-            <a:r>
-              <a:t>– The 33% boundary is the Indian NDRF/SDRF crop-loss relief threshold — not a round number</a:t>
-            </a:r>
-          </a:p>
-          <a:p>
-            <a:pPr lvl="1">
+                  <a:srgbClr val="0F233E"/>
+                </a:solidFill>
+              </a:defRPr>
+            </a:pPr>
+            <a:r>
+              <a:t>• Flood-fraction regression loss</a:t>
+            </a:r>
+          </a:p>
+          <a:p>
+            <a:pPr>
               <a:spcAft>
-                <a:spcPts val="800"/>
+                <a:spcPts val="700"/>
               </a:spcAft>
               <a:defRPr sz="1200">
                 <a:solidFill>
-                  <a:srgbClr val="475569"/>
-                </a:solidFill>
-              </a:defRPr>
-            </a:pPr>
-            <a:r>
-              <a:t>– Permanent water is subtracted because a tile containing a river is not a damaged tile</a:t>
+                  <a:srgbClr val="0F233E"/>
+                </a:solidFill>
+              </a:defRPr>
+            </a:pPr>
+            <a:r>
+              <a:t>• Dihedral augmentation (8×) + crop + coarse dropout</a:t>
+            </a:r>
+          </a:p>
+          <a:p>
+            <a:pPr>
+              <a:spcAft>
+                <a:spcPts val="700"/>
+              </a:spcAft>
+              <a:defRPr sz="1200">
+                <a:solidFill>
+                  <a:srgbClr val="0F233E"/>
+                </a:solidFill>
+              </a:defRPr>
+            </a:pPr>
+            <a:r>
+              <a:t>• Regularisation raised at the start, not reactively</a:t>
+            </a:r>
+          </a:p>
+          <a:p>
+            <a:pPr>
+              <a:spcAft>
+                <a:spcPts val="700"/>
+              </a:spcAft>
+              <a:defRPr sz="1200">
+                <a:solidFill>
+                  <a:srgbClr val="0F233E"/>
+                </a:solidFill>
+              </a:defRPr>
+            </a:pPr>
+            <a:r>
+              <a:t>• Frequency-aware sampling (α = 0.5)</a:t>
+            </a:r>
+          </a:p>
+          <a:p>
+            <a:pPr>
+              <a:spcAft>
+                <a:spcPts val="700"/>
+              </a:spcAft>
+              <a:defRPr sz="1200">
+                <a:solidFill>
+                  <a:srgbClr val="0F233E"/>
+                </a:solidFill>
+              </a:defRPr>
+            </a:pPr>
+            <a:r>
+              <a:t>• Temperature-scaled confidence</a:t>
+            </a:r>
+          </a:p>
+        </p:txBody>
+      </p:sp>
+      <p:sp>
+        <p:nvSpPr>
+          <p:cNvPr id="5" name="TextBox 4"/>
+          <p:cNvSpPr txBox="1"/>
+          <p:nvPr/>
+        </p:nvSpPr>
+        <p:spPr>
+          <a:xfrm>
+            <a:off x="548640" y="3977639"/>
+            <a:ext cx="5486400" cy="1463040"/>
+          </a:xfrm>
+          <a:prstGeom prst="rect">
+            <a:avLst/>
+          </a:prstGeom>
+          <a:noFill/>
+        </p:spPr>
+        <p:txBody>
+          <a:bodyPr wrap="square">
+            <a:spAutoFit/>
+          </a:bodyPr>
+          <a:lstStyle/>
+          <a:p>
+            <a:pPr>
+              <a:defRPr sz="1200" i="1">
+                <a:solidFill>
+                  <a:srgbClr val="B45309"/>
+                </a:solidFill>
+              </a:defRPr>
+            </a:pPr>
+            <a:r>
+              <a:t>Note what is NOT on that list: training longer. A model that peaks at epoch 1 does not improve at epoch 40. The freed compute bought better estimates and stronger regularisation instead.</a:t>
             </a:r>
           </a:p>
         </p:txBody>
@@ -6710,7 +8867,7 @@
               </a:defRPr>
             </a:pPr>
             <a:r>
-              <a:t>Progressive data scaling</a:t>
+              <a:t>Data</a:t>
             </a:r>
           </a:p>
           <a:p>
@@ -6722,533 +8879,21 @@
               </a:defRPr>
             </a:pPr>
             <a:r>
-              <a:t>Start small; step up only as far as the machine demonstrably sustains</a:t>
-            </a:r>
-          </a:p>
-        </p:txBody>
-      </p:sp>
-      <p:graphicFrame>
-        <p:nvGraphicFramePr>
-          <p:cNvPr id="3" name="Table 2"/>
-          <p:cNvGraphicFramePr>
-            <a:graphicFrameLocks noGrp="1"/>
-          </p:cNvGraphicFramePr>
-          <p:nvPr/>
-        </p:nvGraphicFramePr>
-        <p:xfrm>
-          <a:off x="640080" y="1371600"/>
-          <a:ext cx="6583680" cy="2651760"/>
-        </p:xfrm>
-        <a:graphic>
-          <a:graphicData uri="http://schemas.openxmlformats.org/drawingml/2006/table">
-            <a:tbl>
-              <a:tblPr firstRow="1" bandRow="1">
-                <a:tableStyleId>{5C22544A-7EE6-4342-B048-85BDC9FD1C3A}</a:tableStyleId>
-              </a:tblPr>
-              <a:tblGrid>
-                <a:gridCol w="1645920"/>
-                <a:gridCol w="1645920"/>
-                <a:gridCol w="1645920"/>
-                <a:gridCol w="1645920"/>
-              </a:tblGrid>
-              <a:tr h="441960">
-                <a:tc>
-                  <a:txBody>
-                    <a:bodyPr/>
-                    <a:lstStyle/>
-                    <a:p>
-                      <a:pPr>
-                        <a:defRPr sz="1100" b="1">
-                          <a:solidFill>
-                            <a:srgbClr val="FFFFFF"/>
-                          </a:solidFill>
-                        </a:defRPr>
-                      </a:pPr>
-                      <a:r>
-                        <a:t>Tier</a:t>
-                      </a:r>
-                    </a:p>
-                  </a:txBody>
-                  <a:tcPr>
-                    <a:solidFill>
-                      <a:srgbClr val="0F233E"/>
-                    </a:solidFill>
-                  </a:tcPr>
-                </a:tc>
-                <a:tc>
-                  <a:txBody>
-                    <a:bodyPr/>
-                    <a:lstStyle/>
-                    <a:p>
-                      <a:pPr>
-                        <a:defRPr sz="1100" b="1">
-                          <a:solidFill>
-                            <a:srgbClr val="FFFFFF"/>
-                          </a:solidFill>
-                        </a:defRPr>
-                      </a:pPr>
-                      <a:r>
-                        <a:t>Tiles</a:t>
-                      </a:r>
-                    </a:p>
-                  </a:txBody>
-                  <a:tcPr>
-                    <a:solidFill>
-                      <a:srgbClr val="0F233E"/>
-                    </a:solidFill>
-                  </a:tcPr>
-                </a:tc>
-                <a:tc>
-                  <a:txBody>
-                    <a:bodyPr/>
-                    <a:lstStyle/>
-                    <a:p>
-                      <a:pPr>
-                        <a:defRPr sz="1100" b="1">
-                          <a:solidFill>
-                            <a:srgbClr val="FFFFFF"/>
-                          </a:solidFill>
-                        </a:defRPr>
-                      </a:pPr>
-                      <a:r>
-                        <a:t>Size</a:t>
-                      </a:r>
-                    </a:p>
-                  </a:txBody>
-                  <a:tcPr>
-                    <a:solidFill>
-                      <a:srgbClr val="0F233E"/>
-                    </a:solidFill>
-                  </a:tcPr>
-                </a:tc>
-                <a:tc>
-                  <a:txBody>
-                    <a:bodyPr/>
-                    <a:lstStyle/>
-                    <a:p>
-                      <a:pPr>
-                        <a:defRPr sz="1100" b="1">
-                          <a:solidFill>
-                            <a:srgbClr val="FFFFFF"/>
-                          </a:solidFill>
-                        </a:defRPr>
-                      </a:pPr>
-                      <a:r>
-                        <a:t>Purpose</a:t>
-                      </a:r>
-                    </a:p>
-                  </a:txBody>
-                  <a:tcPr>
-                    <a:solidFill>
-                      <a:srgbClr val="0F233E"/>
-                    </a:solidFill>
-                  </a:tcPr>
-                </a:tc>
-              </a:tr>
-              <a:tr h="441960">
-                <a:tc>
-                  <a:txBody>
-                    <a:bodyPr/>
-                    <a:lstStyle/>
-                    <a:p>
-                      <a:pPr>
-                        <a:defRPr sz="1100">
-                          <a:solidFill>
-                            <a:srgbClr val="0F233E"/>
-                          </a:solidFill>
-                        </a:defRPr>
-                      </a:pPr>
-                      <a:r>
-                        <a:t>T0_smoke</a:t>
-                      </a:r>
-                    </a:p>
-                  </a:txBody>
-                  <a:tcPr/>
-                </a:tc>
-                <a:tc>
-                  <a:txBody>
-                    <a:bodyPr/>
-                    <a:lstStyle/>
-                    <a:p>
-                      <a:pPr>
-                        <a:defRPr sz="1100">
-                          <a:solidFill>
-                            <a:srgbClr val="0F233E"/>
-                          </a:solidFill>
-                        </a:defRPr>
-                      </a:pPr>
-                      <a:r>
-                        <a:t>40</a:t>
-                      </a:r>
-                    </a:p>
-                  </a:txBody>
-                  <a:tcPr/>
-                </a:tc>
-                <a:tc>
-                  <a:txBody>
-                    <a:bodyPr/>
-                    <a:lstStyle/>
-                    <a:p>
-                      <a:pPr>
-                        <a:defRPr sz="1100">
-                          <a:solidFill>
-                            <a:srgbClr val="0F233E"/>
-                          </a:solidFill>
-                        </a:defRPr>
-                      </a:pPr>
-                      <a:r>
-                        <a:t>128 px</a:t>
-                      </a:r>
-                    </a:p>
-                  </a:txBody>
-                  <a:tcPr/>
-                </a:tc>
-                <a:tc>
-                  <a:txBody>
-                    <a:bodyPr/>
-                    <a:lstStyle/>
-                    <a:p>
-                      <a:pPr>
-                        <a:defRPr sz="1100">
-                          <a:solidFill>
-                            <a:srgbClr val="0F233E"/>
-                          </a:solidFill>
-                        </a:defRPr>
-                      </a:pPr>
-                      <a:r>
-                        <a:t>Pipeline proof — offline, runs in CI</a:t>
-                      </a:r>
-                    </a:p>
-                  </a:txBody>
-                  <a:tcPr/>
-                </a:tc>
-              </a:tr>
-              <a:tr h="441960">
-                <a:tc>
-                  <a:txBody>
-                    <a:bodyPr/>
-                    <a:lstStyle/>
-                    <a:p>
-                      <a:pPr>
-                        <a:defRPr sz="1100">
-                          <a:solidFill>
-                            <a:srgbClr val="0F233E"/>
-                          </a:solidFill>
-                        </a:defRPr>
-                      </a:pPr>
-                      <a:r>
-                        <a:t>T1_tiny</a:t>
-                      </a:r>
-                    </a:p>
-                  </a:txBody>
-                  <a:tcPr/>
-                </a:tc>
-                <a:tc>
-                  <a:txBody>
-                    <a:bodyPr/>
-                    <a:lstStyle/>
-                    <a:p>
-                      <a:pPr>
-                        <a:defRPr sz="1100">
-                          <a:solidFill>
-                            <a:srgbClr val="0F233E"/>
-                          </a:solidFill>
-                        </a:defRPr>
-                      </a:pPr>
-                      <a:r>
-                        <a:t>150</a:t>
-                      </a:r>
-                    </a:p>
-                  </a:txBody>
-                  <a:tcPr/>
-                </a:tc>
-                <a:tc>
-                  <a:txBody>
-                    <a:bodyPr/>
-                    <a:lstStyle/>
-                    <a:p>
-                      <a:pPr>
-                        <a:defRPr sz="1100">
-                          <a:solidFill>
-                            <a:srgbClr val="0F233E"/>
-                          </a:solidFill>
-                        </a:defRPr>
-                      </a:pPr>
-                      <a:r>
-                        <a:t>128 px</a:t>
-                      </a:r>
-                    </a:p>
-                  </a:txBody>
-                  <a:tcPr/>
-                </a:tc>
-                <a:tc>
-                  <a:txBody>
-                    <a:bodyPr/>
-                    <a:lstStyle/>
-                    <a:p>
-                      <a:pPr>
-                        <a:defRPr sz="1100">
-                          <a:solidFill>
-                            <a:srgbClr val="0F233E"/>
-                          </a:solidFill>
-                        </a:defRPr>
-                      </a:pPr>
-                      <a:r>
-                        <a:t>First real data</a:t>
-                      </a:r>
-                    </a:p>
-                  </a:txBody>
-                  <a:tcPr/>
-                </a:tc>
-              </a:tr>
-              <a:tr h="441960">
-                <a:tc>
-                  <a:txBody>
-                    <a:bodyPr/>
-                    <a:lstStyle/>
-                    <a:p>
-                      <a:pPr>
-                        <a:defRPr sz="1100">
-                          <a:solidFill>
-                            <a:srgbClr val="0F233E"/>
-                          </a:solidFill>
-                        </a:defRPr>
-                      </a:pPr>
-                      <a:r>
-                        <a:t>T2_small</a:t>
-                      </a:r>
-                    </a:p>
-                  </a:txBody>
-                  <a:tcPr/>
-                </a:tc>
-                <a:tc>
-                  <a:txBody>
-                    <a:bodyPr/>
-                    <a:lstStyle/>
-                    <a:p>
-                      <a:pPr>
-                        <a:defRPr sz="1100">
-                          <a:solidFill>
-                            <a:srgbClr val="0F233E"/>
-                          </a:solidFill>
-                        </a:defRPr>
-                      </a:pPr>
-                      <a:r>
-                        <a:t>400</a:t>
-                      </a:r>
-                    </a:p>
-                  </a:txBody>
-                  <a:tcPr/>
-                </a:tc>
-                <a:tc>
-                  <a:txBody>
-                    <a:bodyPr/>
-                    <a:lstStyle/>
-                    <a:p>
-                      <a:pPr>
-                        <a:defRPr sz="1100">
-                          <a:solidFill>
-                            <a:srgbClr val="0F233E"/>
-                          </a:solidFill>
-                        </a:defRPr>
-                      </a:pPr>
-                      <a:r>
-                        <a:t>192 px</a:t>
-                      </a:r>
-                    </a:p>
-                  </a:txBody>
-                  <a:tcPr/>
-                </a:tc>
-                <a:tc>
-                  <a:txBody>
-                    <a:bodyPr/>
-                    <a:lstStyle/>
-                    <a:p>
-                      <a:pPr>
-                        <a:defRPr sz="1100">
-                          <a:solidFill>
-                            <a:srgbClr val="0F233E"/>
-                          </a:solidFill>
-                        </a:defRPr>
-                      </a:pPr>
-                      <a:r>
-                        <a:t>First meaningful signal</a:t>
-                      </a:r>
-                    </a:p>
-                  </a:txBody>
-                  <a:tcPr/>
-                </a:tc>
-              </a:tr>
-              <a:tr h="441960">
-                <a:tc>
-                  <a:txBody>
-                    <a:bodyPr/>
-                    <a:lstStyle/>
-                    <a:p>
-                      <a:pPr>
-                        <a:defRPr sz="1100">
-                          <a:solidFill>
-                            <a:srgbClr val="0F233E"/>
-                          </a:solidFill>
-                        </a:defRPr>
-                      </a:pPr>
-                      <a:r>
-                        <a:t>T3_medium</a:t>
-                      </a:r>
-                    </a:p>
-                  </a:txBody>
-                  <a:tcPr/>
-                </a:tc>
-                <a:tc>
-                  <a:txBody>
-                    <a:bodyPr/>
-                    <a:lstStyle/>
-                    <a:p>
-                      <a:pPr>
-                        <a:defRPr sz="1100">
-                          <a:solidFill>
-                            <a:srgbClr val="0F233E"/>
-                          </a:solidFill>
-                        </a:defRPr>
-                      </a:pPr>
-                      <a:r>
-                        <a:t>900</a:t>
-                      </a:r>
-                    </a:p>
-                  </a:txBody>
-                  <a:tcPr/>
-                </a:tc>
-                <a:tc>
-                  <a:txBody>
-                    <a:bodyPr/>
-                    <a:lstStyle/>
-                    <a:p>
-                      <a:pPr>
-                        <a:defRPr sz="1100">
-                          <a:solidFill>
-                            <a:srgbClr val="0F233E"/>
-                          </a:solidFill>
-                        </a:defRPr>
-                      </a:pPr>
-                      <a:r>
-                        <a:t>256 px</a:t>
-                      </a:r>
-                    </a:p>
-                  </a:txBody>
-                  <a:tcPr/>
-                </a:tc>
-                <a:tc>
-                  <a:txBody>
-                    <a:bodyPr/>
-                    <a:lstStyle/>
-                    <a:p>
-                      <a:pPr>
-                        <a:defRPr sz="1100">
-                          <a:solidFill>
-                            <a:srgbClr val="0F233E"/>
-                          </a:solidFill>
-                        </a:defRPr>
-                      </a:pPr>
-                      <a:r>
-                        <a:t>Target tier</a:t>
-                      </a:r>
-                    </a:p>
-                  </a:txBody>
-                  <a:tcPr/>
-                </a:tc>
-              </a:tr>
-              <a:tr h="441960">
-                <a:tc>
-                  <a:txBody>
-                    <a:bodyPr/>
-                    <a:lstStyle/>
-                    <a:p>
-                      <a:pPr>
-                        <a:defRPr sz="1100">
-                          <a:solidFill>
-                            <a:srgbClr val="0F233E"/>
-                          </a:solidFill>
-                        </a:defRPr>
-                      </a:pPr>
-                      <a:r>
-                        <a:t>T4_large</a:t>
-                      </a:r>
-                    </a:p>
-                  </a:txBody>
-                  <a:tcPr/>
-                </a:tc>
-                <a:tc>
-                  <a:txBody>
-                    <a:bodyPr/>
-                    <a:lstStyle/>
-                    <a:p>
-                      <a:pPr>
-                        <a:defRPr sz="1100">
-                          <a:solidFill>
-                            <a:srgbClr val="0F233E"/>
-                          </a:solidFill>
-                        </a:defRPr>
-                      </a:pPr>
-                      <a:r>
-                        <a:t>1800</a:t>
-                      </a:r>
-                    </a:p>
-                  </a:txBody>
-                  <a:tcPr/>
-                </a:tc>
-                <a:tc>
-                  <a:txBody>
-                    <a:bodyPr/>
-                    <a:lstStyle/>
-                    <a:p>
-                      <a:pPr>
-                        <a:defRPr sz="1100">
-                          <a:solidFill>
-                            <a:srgbClr val="0F233E"/>
-                          </a:solidFill>
-                        </a:defRPr>
-                      </a:pPr>
-                      <a:r>
-                        <a:t>256 px</a:t>
-                      </a:r>
-                    </a:p>
-                  </a:txBody>
-                  <a:tcPr/>
-                </a:tc>
-                <a:tc>
-                  <a:txBody>
-                    <a:bodyPr/>
-                    <a:lstStyle/>
-                    <a:p>
-                      <a:pPr>
-                        <a:defRPr sz="1100">
-                          <a:solidFill>
-                            <a:srgbClr val="0F233E"/>
-                          </a:solidFill>
-                        </a:defRPr>
-                      </a:pPr>
-                      <a:r>
-                        <a:t>Only if T3 finished comfortably</a:t>
-                      </a:r>
-                    </a:p>
-                  </a:txBody>
-                  <a:tcPr/>
-                </a:tc>
-              </a:tr>
-            </a:tbl>
-          </a:graphicData>
-        </a:graphic>
-      </p:graphicFrame>
-      <p:sp>
-        <p:nvSpPr>
-          <p:cNvPr id="4" name="TextBox 3"/>
+              <a:t>Both sources public, no credentials, nothing bulk-downloaded</a:t>
+            </a:r>
+          </a:p>
+        </p:txBody>
+      </p:sp>
+      <p:sp>
+        <p:nvSpPr>
+          <p:cNvPr id="3" name="TextBox 2"/>
           <p:cNvSpPr txBox="1"/>
           <p:nvPr/>
         </p:nvSpPr>
         <p:spPr>
           <a:xfrm>
-            <a:off x="7498079" y="1463040"/>
-            <a:ext cx="4206240" cy="4846320"/>
+            <a:off x="640080" y="1417320"/>
+            <a:ext cx="10972800" cy="4846320"/>
           </a:xfrm>
           <a:prstGeom prst="rect">
             <a:avLst/>
@@ -7263,61 +8908,136 @@
           <a:p>
             <a:pPr>
               <a:spcAft>
-                <a:spcPts val="1000"/>
+                <a:spcPts val="800"/>
+              </a:spcAft>
+              <a:defRPr sz="1400">
+                <a:solidFill>
+                  <a:srgbClr val="0F233E"/>
+                </a:solidFill>
+              </a:defRPr>
+            </a:pPr>
+            <a:r>
+              <a:t>• Imagery — ETCI-2021 Sentinel-1 SAR over Bangladesh (Ganges–Brahmaputra delta)</a:t>
+            </a:r>
+          </a:p>
+          <a:p>
+            <a:pPr lvl="1">
+              <a:spcAft>
+                <a:spcPts val="800"/>
               </a:spcAft>
               <a:defRPr sz="1200">
                 <a:solidFill>
-                  <a:srgbClr val="0F233E"/>
-                </a:solidFill>
-              </a:defRPr>
-            </a:pPr>
-            <a:r>
-              <a:t>• After each tier we measure peak RSS, free disk and seconds/epoch</a:t>
-            </a:r>
-          </a:p>
-          <a:p>
-            <a:pPr>
+                  <a:srgbClr val="475569"/>
+                </a:solidFill>
+              </a:defRPr>
+            </a:pPr>
+            <a:r>
+              <a:t>– 2,032 tiles with a genuine pre/post pair: 2017-03-14 pre-monsoon and 2017-06-06 monsoon flood</a:t>
+            </a:r>
+          </a:p>
+          <a:p>
+            <a:pPr lvl="1">
               <a:spcAft>
-                <a:spcPts val="1000"/>
+                <a:spcPts val="800"/>
               </a:spcAft>
               <a:defRPr sz="1200">
                 <a:solidFill>
+                  <a:srgbClr val="475569"/>
+                </a:solidFill>
+              </a:defRPr>
+            </a:pPr>
+            <a:r>
+              <a:t>– Each carries VV, VH, a flood mask and a permanent-water mask at both dates</a:t>
+            </a:r>
+          </a:p>
+          <a:p>
+            <a:pPr>
+              <a:spcAft>
+                <a:spcPts val="800"/>
+              </a:spcAft>
+              <a:defRPr sz="1400">
+                <a:solidFill>
                   <a:srgbClr val="0F233E"/>
                 </a:solidFill>
               </a:defRPr>
             </a:pPr>
             <a:r>
-              <a:t>• Advance only if the next tier stays under a 6 GB disk floor, 70% of RAM and the time budget</a:t>
-            </a:r>
-          </a:p>
-          <a:p>
-            <a:pPr>
+              <a:t>• Agriculture — ICRISAT district statistics: 310 Indian districts · 23 crops · 2010–2017</a:t>
+            </a:r>
+          </a:p>
+          <a:p>
+            <a:pPr lvl="1">
               <a:spcAft>
-                <a:spcPts val="1000"/>
+                <a:spcPts val="800"/>
               </a:spcAft>
               <a:defRPr sz="1200">
                 <a:solidFill>
+                  <a:srgbClr val="475569"/>
+                </a:solidFill>
+              </a:defRPr>
+            </a:pPr>
+            <a:r>
+              <a:t>– Label from per-district yield anomaly → a real 10.9 : 1 class imbalance, which is what justifies SMOTE</a:t>
+            </a:r>
+          </a:p>
+          <a:p>
+            <a:pPr>
+              <a:spcAft>
+                <a:spcPts val="800"/>
+              </a:spcAft>
+              <a:defRPr sz="1400">
+                <a:solidFill>
                   <a:srgbClr val="0F233E"/>
                 </a:solidFill>
               </a:defRPr>
             </a:pPr>
             <a:r>
-              <a:t>• Otherwise stop at the last good tier and record why — in reports/scaling_log.json</a:t>
+              <a:t>• </a:t>
             </a:r>
           </a:p>
           <a:p>
             <a:pPr>
               <a:spcAft>
-                <a:spcPts val="1000"/>
+                <a:spcPts val="800"/>
+              </a:spcAft>
+              <a:defRPr sz="1400">
+                <a:solidFill>
+                  <a:srgbClr val="0F233E"/>
+                </a:solidFill>
+              </a:defRPr>
+            </a:pPr>
+            <a:r>
+              <a:t>• Severity = net flood fraction (flood − permanent water), binned at 2% / 10% / 33%</a:t>
+            </a:r>
+          </a:p>
+          <a:p>
+            <a:pPr lvl="1">
+              <a:spcAft>
+                <a:spcPts val="800"/>
               </a:spcAft>
               <a:defRPr sz="1200">
                 <a:solidFill>
-                  <a:srgbClr val="0F233E"/>
-                </a:solidFill>
-              </a:defRPr>
-            </a:pPr>
-            <a:r>
-              <a:t>• A complete five-model table exists after the first tier, so there is always something to show</a:t>
+                  <a:srgbClr val="475569"/>
+                </a:solidFill>
+              </a:defRPr>
+            </a:pPr>
+            <a:r>
+              <a:t>– The 33% boundary is the Indian NDRF/SDRF crop-loss relief threshold — not a round number</a:t>
+            </a:r>
+          </a:p>
+          <a:p>
+            <a:pPr lvl="1">
+              <a:spcAft>
+                <a:spcPts val="800"/>
+              </a:spcAft>
+              <a:defRPr sz="1200">
+                <a:solidFill>
+                  <a:srgbClr val="475569"/>
+                </a:solidFill>
+              </a:defRPr>
+            </a:pPr>
+            <a:r>
+              <a:t>– Permanent water is subtracted because a tile containing a river is not a damaged tile</a:t>
             </a:r>
           </a:p>
         </p:txBody>

</xml_diff>

<commit_message>
fix(app): apply the calibrated confidence; rank result tables by score
The app read reports/cv_results.json directly, which does not exist when the models are run
separately and merged from their per-model files -- so load_temperature silently returned 1.0
and the demo showed raw uncalibrated softmax (35.4% where the calibrated value is 43.9%).
It now uses the same loader as the report.

Team brief carries the final cross-validated numbers.
</commit_message>
<xml_diff>
--- a/slides/Techathon_PS6.pptx
+++ b/slides/Techathon_PS6.pptx
@@ -4163,7 +4163,7 @@
                         </a:defRPr>
                       </a:pPr>
                       <a:r>
-                        <a:t>CNN + LSTM</a:t>
+                        <a:t>YOLO12 + U-Net</a:t>
                       </a:r>
                     </a:p>
                   </a:txBody>
@@ -4182,7 +4182,7 @@
                         </a:defRPr>
                       </a:pPr>
                       <a:r>
-                        <a:t>9.0M</a:t>
+                        <a:t>5.5M</a:t>
                       </a:r>
                     </a:p>
                   </a:txBody>
@@ -4201,7 +4201,7 @@
                         </a:defRPr>
                       </a:pPr>
                       <a:r>
-                        <a:t>0.459</a:t>
+                        <a:t>0.462</a:t>
                       </a:r>
                     </a:p>
                   </a:txBody>
@@ -4220,7 +4220,7 @@
                         </a:defRPr>
                       </a:pPr>
                       <a:r>
-                        <a:t>±0.041</a:t>
+                        <a:t>±0.048</a:t>
                       </a:r>
                     </a:p>
                   </a:txBody>
@@ -4239,7 +4239,7 @@
                         </a:defRPr>
                       </a:pPr>
                       <a:r>
-                        <a:t>0.688</a:t>
+                        <a:t>0.713</a:t>
                       </a:r>
                     </a:p>
                   </a:txBody>
@@ -4258,7 +4258,7 @@
                         </a:defRPr>
                       </a:pPr>
                       <a:r>
-                        <a:t>0.391</a:t>
+                        <a:t>0.388</a:t>
                       </a:r>
                     </a:p>
                   </a:txBody>
@@ -4277,7 +4277,7 @@
                         </a:defRPr>
                       </a:pPr>
                       <a:r>
-                        <a:t>0.190</a:t>
+                        <a:t>0.205</a:t>
                       </a:r>
                     </a:p>
                   </a:txBody>
@@ -4296,7 +4296,7 @@
                         </a:defRPr>
                       </a:pPr>
                       <a:r>
-                        <a:t>-0.096 ✅</a:t>
+                        <a:t>-0.076 ✅</a:t>
                       </a:r>
                     </a:p>
                   </a:txBody>
@@ -4317,7 +4317,7 @@
                         </a:defRPr>
                       </a:pPr>
                       <a:r>
-                        <a:t>YOLO12 + U-Net</a:t>
+                        <a:t>CNN + LSTM</a:t>
                       </a:r>
                     </a:p>
                   </a:txBody>
@@ -4336,7 +4336,7 @@
                         </a:defRPr>
                       </a:pPr>
                       <a:r>
-                        <a:t>5.5M</a:t>
+                        <a:t>9.0M</a:t>
                       </a:r>
                     </a:p>
                   </a:txBody>
@@ -4355,7 +4355,7 @@
                         </a:defRPr>
                       </a:pPr>
                       <a:r>
-                        <a:t>0.462</a:t>
+                        <a:t>0.459</a:t>
                       </a:r>
                     </a:p>
                   </a:txBody>
@@ -4374,7 +4374,7 @@
                         </a:defRPr>
                       </a:pPr>
                       <a:r>
-                        <a:t>±0.048</a:t>
+                        <a:t>±0.041</a:t>
                       </a:r>
                     </a:p>
                   </a:txBody>
@@ -4393,7 +4393,7 @@
                         </a:defRPr>
                       </a:pPr>
                       <a:r>
-                        <a:t>0.713</a:t>
+                        <a:t>0.688</a:t>
                       </a:r>
                     </a:p>
                   </a:txBody>
@@ -4412,7 +4412,7 @@
                         </a:defRPr>
                       </a:pPr>
                       <a:r>
-                        <a:t>0.388</a:t>
+                        <a:t>0.391</a:t>
                       </a:r>
                     </a:p>
                   </a:txBody>
@@ -4431,7 +4431,7 @@
                         </a:defRPr>
                       </a:pPr>
                       <a:r>
-                        <a:t>0.205</a:t>
+                        <a:t>0.190</a:t>
                       </a:r>
                     </a:p>
                   </a:txBody>
@@ -4450,7 +4450,7 @@
                         </a:defRPr>
                       </a:pPr>
                       <a:r>
-                        <a:t>-0.076 ✅</a:t>
+                        <a:t>-0.096 ✅</a:t>
                       </a:r>
                     </a:p>
                   </a:txBody>
@@ -4652,7 +4652,7 @@
                         </a:defRPr>
                       </a:pPr>
                       <a:r>
-                        <a:t>CNN + LSTM</a:t>
+                        <a:t>YOLO12 + U-Net</a:t>
                       </a:r>
                     </a:p>
                   </a:txBody>
@@ -4671,7 +4671,7 @@
                         </a:defRPr>
                       </a:pPr>
                       <a:r>
-                        <a:t>0.934</a:t>
+                        <a:t>0.951</a:t>
                       </a:r>
                     </a:p>
                   </a:txBody>
@@ -4690,7 +4690,7 @@
                         </a:defRPr>
                       </a:pPr>
                       <a:r>
-                        <a:t>0.383</a:t>
+                        <a:t>0.338</a:t>
                       </a:r>
                     </a:p>
                   </a:txBody>
@@ -4709,7 +4709,7 @@
                         </a:defRPr>
                       </a:pPr>
                       <a:r>
-                        <a:t>0.790</a:t>
+                        <a:t>0.798</a:t>
                       </a:r>
                     </a:p>
                   </a:txBody>
@@ -4728,7 +4728,7 @@
                         </a:defRPr>
                       </a:pPr>
                       <a:r>
-                        <a:t>0.692</a:t>
+                        <a:t>0.664</a:t>
                       </a:r>
                     </a:p>
                   </a:txBody>
@@ -4749,7 +4749,7 @@
                         </a:defRPr>
                       </a:pPr>
                       <a:r>
-                        <a:t>YOLO12 + U-Net</a:t>
+                        <a:t>CNN + LSTM</a:t>
                       </a:r>
                     </a:p>
                   </a:txBody>
@@ -4768,7 +4768,7 @@
                         </a:defRPr>
                       </a:pPr>
                       <a:r>
-                        <a:t>0.951</a:t>
+                        <a:t>0.934</a:t>
                       </a:r>
                     </a:p>
                   </a:txBody>
@@ -4787,7 +4787,7 @@
                         </a:defRPr>
                       </a:pPr>
                       <a:r>
-                        <a:t>0.338</a:t>
+                        <a:t>0.383</a:t>
                       </a:r>
                     </a:p>
                   </a:txBody>
@@ -4806,7 +4806,7 @@
                         </a:defRPr>
                       </a:pPr>
                       <a:r>
-                        <a:t>0.798</a:t>
+                        <a:t>0.790</a:t>
                       </a:r>
                     </a:p>
                   </a:txBody>
@@ -4825,7 +4825,7 @@
                         </a:defRPr>
                       </a:pPr>
                       <a:r>
-                        <a:t>0.664</a:t>
+                        <a:t>0.692</a:t>
                       </a:r>
                     </a:p>
                   </a:txBody>
@@ -5116,7 +5116,7 @@
                         </a:defRPr>
                       </a:pPr>
                       <a:r>
-                        <a:t>CNN + LSTM</a:t>
+                        <a:t>YOLO12 + U-Net</a:t>
                       </a:r>
                     </a:p>
                   </a:txBody>
@@ -5135,7 +5135,7 @@
                         </a:defRPr>
                       </a:pPr>
                       <a:r>
-                        <a:t>0.521</a:t>
+                        <a:t>0.476</a:t>
                       </a:r>
                     </a:p>
                   </a:txBody>
@@ -5154,7 +5154,7 @@
                         </a:defRPr>
                       </a:pPr>
                       <a:r>
-                        <a:t>0.157</a:t>
+                        <a:t>0.163</a:t>
                       </a:r>
                     </a:p>
                   </a:txBody>
@@ -5173,7 +5173,7 @@
                         </a:defRPr>
                       </a:pPr>
                       <a:r>
-                        <a:t>0.067</a:t>
+                        <a:t>0.078</a:t>
                       </a:r>
                     </a:p>
                   </a:txBody>
@@ -5192,7 +5192,7 @@
                         </a:defRPr>
                       </a:pPr>
                       <a:r>
-                        <a:t>59.4% → 72.7%</a:t>
+                        <a:t>61.0% → 76.9%</a:t>
                       </a:r>
                     </a:p>
                   </a:txBody>
@@ -5232,7 +5232,7 @@
                         </a:defRPr>
                       </a:pPr>
                       <a:r>
-                        <a:t>YOLO12 + U-Net</a:t>
+                        <a:t>CNN + LSTM</a:t>
                       </a:r>
                     </a:p>
                   </a:txBody>
@@ -5251,7 +5251,7 @@
                         </a:defRPr>
                       </a:pPr>
                       <a:r>
-                        <a:t>0.476</a:t>
+                        <a:t>0.521</a:t>
                       </a:r>
                     </a:p>
                   </a:txBody>
@@ -5270,7 +5270,7 @@
                         </a:defRPr>
                       </a:pPr>
                       <a:r>
-                        <a:t>0.163</a:t>
+                        <a:t>0.157</a:t>
                       </a:r>
                     </a:p>
                   </a:txBody>
@@ -5289,7 +5289,7 @@
                         </a:defRPr>
                       </a:pPr>
                       <a:r>
-                        <a:t>0.078</a:t>
+                        <a:t>0.067</a:t>
                       </a:r>
                     </a:p>
                   </a:txBody>
@@ -5308,7 +5308,7 @@
                         </a:defRPr>
                       </a:pPr>
                       <a:r>
-                        <a:t>61.0% → 76.9%</a:t>
+                        <a:t>59.4% → 72.7%</a:t>
                       </a:r>
                     </a:p>
                   </a:txBody>

</xml_diff>